<commit_message>
Update assessment deck for bundle deployment, seed job and Stage A alerting
Refresh the jobs slide (4 orchestrated jobs incl. seed), catalog name, test
coverage (105 tests / 9 files), promotion and de-duplication behaviour,
code-column rule, and mark Stage A alerting as delivered. Generator now
writes next to itself instead of a hardcoded /home/user path.

Co-Authored-By: Claude Sonnet 5.5 <noreply@anthropic.com>
</commit_message>
<xml_diff>
--- a/AI_Infusion_Delivery_Assessment.pptx
+++ b/AI_Infusion_Delivery_Assessment.pptx
@@ -3437,7 +3437,7 @@
                   <a:srgbClr val="0F3460"/>
                 </a:solidFill>
               </a:rPr>
-              <a:t>POC Overview — Five Working Phases</a:t>
+              <a:t>POC Overview — Five Phases plus Stage A</a:t>
             </a:r>
           </a:p>
         </p:txBody>
@@ -5341,14 +5341,14 @@
         </p:nvSpPr>
         <p:spPr>
           <a:xfrm>
-            <a:off x="457200" y="5074920"/>
-            <a:ext cx="11247120" cy="1280160"/>
-          </a:xfrm>
-          <a:prstGeom prst="rect">
-            <a:avLst/>
-          </a:prstGeom>
-          <a:solidFill>
-            <a:srgbClr val="F7F9FC"/>
+            <a:off x="457200" y="3630168"/>
+            <a:ext cx="457200" cy="347472"/>
+          </a:xfrm>
+          <a:prstGeom prst="rect">
+            <a:avLst/>
+          </a:prstGeom>
+          <a:solidFill>
+            <a:srgbClr val="FFFFFF"/>
           </a:solidFill>
           <a:ln>
             <a:noFill/>
@@ -5378,20 +5378,54 @@
       </p:sp>
       <p:sp>
         <p:nvSpPr>
-          <p:cNvPr id="53" name="Rectangle 52"/>
-          <p:cNvSpPr/>
-          <p:nvPr/>
-        </p:nvSpPr>
-        <p:spPr>
-          <a:xfrm>
-            <a:off x="457200" y="5074920"/>
-            <a:ext cx="63500" cy="1280160"/>
-          </a:xfrm>
-          <a:prstGeom prst="rect">
-            <a:avLst/>
-          </a:prstGeom>
-          <a:solidFill>
-            <a:srgbClr val="E94560"/>
+          <p:cNvPr id="53" name="TextBox 52"/>
+          <p:cNvSpPr txBox="1"/>
+          <p:nvPr/>
+        </p:nvSpPr>
+        <p:spPr>
+          <a:xfrm>
+            <a:off x="502920" y="3668268"/>
+            <a:ext cx="365760" cy="347472"/>
+          </a:xfrm>
+          <a:prstGeom prst="rect">
+            <a:avLst/>
+          </a:prstGeom>
+          <a:noFill/>
+        </p:spPr>
+        <p:txBody>
+          <a:bodyPr wrap="square">
+            <a:spAutoFit/>
+          </a:bodyPr>
+          <a:lstStyle/>
+          <a:p>
+            <a:pPr algn="l"/>
+            <a:r>
+              <a:rPr sz="1300" b="0" i="0">
+                <a:solidFill>
+                  <a:srgbClr val="333333"/>
+                </a:solidFill>
+              </a:rPr>
+              <a:t>A</a:t>
+            </a:r>
+          </a:p>
+        </p:txBody>
+      </p:sp>
+      <p:sp>
+        <p:nvSpPr>
+          <p:cNvPr id="54" name="Rectangle 53"/>
+          <p:cNvSpPr/>
+          <p:nvPr/>
+        </p:nvSpPr>
+        <p:spPr>
+          <a:xfrm>
+            <a:off x="914400" y="3630168"/>
+            <a:ext cx="2377440" cy="347472"/>
+          </a:xfrm>
+          <a:prstGeom prst="rect">
+            <a:avLst/>
+          </a:prstGeom>
+          <a:solidFill>
+            <a:srgbClr val="FFFFFF"/>
           </a:solidFill>
           <a:ln>
             <a:noFill/>
@@ -5421,14 +5455,288 @@
       </p:sp>
       <p:sp>
         <p:nvSpPr>
-          <p:cNvPr id="54" name="TextBox 53"/>
-          <p:cNvSpPr txBox="1"/>
-          <p:nvPr/>
-        </p:nvSpPr>
-        <p:spPr>
-          <a:xfrm>
-            <a:off x="685800" y="5166360"/>
-            <a:ext cx="10881360" cy="1097280"/>
+          <p:cNvPr id="55" name="TextBox 54"/>
+          <p:cNvSpPr txBox="1"/>
+          <p:nvPr/>
+        </p:nvSpPr>
+        <p:spPr>
+          <a:xfrm>
+            <a:off x="960120" y="3668268"/>
+            <a:ext cx="2286000" cy="347472"/>
+          </a:xfrm>
+          <a:prstGeom prst="rect">
+            <a:avLst/>
+          </a:prstGeom>
+          <a:noFill/>
+        </p:spPr>
+        <p:txBody>
+          <a:bodyPr wrap="square">
+            <a:spAutoFit/>
+          </a:bodyPr>
+          <a:lstStyle/>
+          <a:p>
+            <a:pPr algn="l"/>
+            <a:r>
+              <a:rPr sz="1300" b="0" i="0">
+                <a:solidFill>
+                  <a:srgbClr val="333333"/>
+                </a:solidFill>
+              </a:rPr>
+              <a:t>Automated Alerting</a:t>
+            </a:r>
+          </a:p>
+        </p:txBody>
+      </p:sp>
+      <p:sp>
+        <p:nvSpPr>
+          <p:cNvPr id="56" name="Rectangle 55"/>
+          <p:cNvSpPr/>
+          <p:nvPr/>
+        </p:nvSpPr>
+        <p:spPr>
+          <a:xfrm>
+            <a:off x="3291840" y="3630168"/>
+            <a:ext cx="6035040" cy="347472"/>
+          </a:xfrm>
+          <a:prstGeom prst="rect">
+            <a:avLst/>
+          </a:prstGeom>
+          <a:solidFill>
+            <a:srgbClr val="FFFFFF"/>
+          </a:solidFill>
+          <a:ln>
+            <a:noFill/>
+          </a:ln>
+        </p:spPr>
+        <p:style>
+          <a:lnRef idx="1">
+            <a:schemeClr val="accent1"/>
+          </a:lnRef>
+          <a:fillRef idx="3">
+            <a:schemeClr val="accent1"/>
+          </a:fillRef>
+          <a:effectRef idx="2">
+            <a:schemeClr val="accent1"/>
+          </a:effectRef>
+          <a:fontRef idx="minor">
+            <a:schemeClr val="lt1"/>
+          </a:fontRef>
+        </p:style>
+        <p:txBody>
+          <a:bodyPr rtlCol="0" anchor="ctr"/>
+          <a:lstStyle/>
+          <a:p>
+            <a:pPr algn="ctr"/>
+          </a:p>
+        </p:txBody>
+      </p:sp>
+      <p:sp>
+        <p:nvSpPr>
+          <p:cNvPr id="57" name="TextBox 56"/>
+          <p:cNvSpPr txBox="1"/>
+          <p:nvPr/>
+        </p:nvSpPr>
+        <p:spPr>
+          <a:xfrm>
+            <a:off x="3337560" y="3668268"/>
+            <a:ext cx="5943600" cy="347472"/>
+          </a:xfrm>
+          <a:prstGeom prst="rect">
+            <a:avLst/>
+          </a:prstGeom>
+          <a:noFill/>
+        </p:spPr>
+        <p:txBody>
+          <a:bodyPr wrap="square">
+            <a:spAutoFit/>
+          </a:bodyPr>
+          <a:lstStyle/>
+          <a:p>
+            <a:pPr algn="l"/>
+            <a:r>
+              <a:rPr sz="1300" b="0" i="0">
+                <a:solidFill>
+                  <a:srgbClr val="333333"/>
+                </a:solidFill>
+              </a:rPr>
+              <a:t>Flags violation-rate spikes vs. each rule's own baseline; audit log</a:t>
+            </a:r>
+          </a:p>
+        </p:txBody>
+      </p:sp>
+      <p:sp>
+        <p:nvSpPr>
+          <p:cNvPr id="58" name="Rectangle 57"/>
+          <p:cNvSpPr/>
+          <p:nvPr/>
+        </p:nvSpPr>
+        <p:spPr>
+          <a:xfrm>
+            <a:off x="9326880" y="3630168"/>
+            <a:ext cx="2377440" cy="347472"/>
+          </a:xfrm>
+          <a:prstGeom prst="rect">
+            <a:avLst/>
+          </a:prstGeom>
+          <a:solidFill>
+            <a:srgbClr val="FFFFFF"/>
+          </a:solidFill>
+          <a:ln>
+            <a:noFill/>
+          </a:ln>
+        </p:spPr>
+        <p:style>
+          <a:lnRef idx="1">
+            <a:schemeClr val="accent1"/>
+          </a:lnRef>
+          <a:fillRef idx="3">
+            <a:schemeClr val="accent1"/>
+          </a:fillRef>
+          <a:effectRef idx="2">
+            <a:schemeClr val="accent1"/>
+          </a:effectRef>
+          <a:fontRef idx="minor">
+            <a:schemeClr val="lt1"/>
+          </a:fontRef>
+        </p:style>
+        <p:txBody>
+          <a:bodyPr rtlCol="0" anchor="ctr"/>
+          <a:lstStyle/>
+          <a:p>
+            <a:pPr algn="ctr"/>
+          </a:p>
+        </p:txBody>
+      </p:sp>
+      <p:sp>
+        <p:nvSpPr>
+          <p:cNvPr id="59" name="TextBox 58"/>
+          <p:cNvSpPr txBox="1"/>
+          <p:nvPr/>
+        </p:nvSpPr>
+        <p:spPr>
+          <a:xfrm>
+            <a:off x="9372600" y="3668268"/>
+            <a:ext cx="2286000" cy="347472"/>
+          </a:xfrm>
+          <a:prstGeom prst="rect">
+            <a:avLst/>
+          </a:prstGeom>
+          <a:noFill/>
+        </p:spPr>
+        <p:txBody>
+          <a:bodyPr wrap="square">
+            <a:spAutoFit/>
+          </a:bodyPr>
+          <a:lstStyle/>
+          <a:p>
+            <a:pPr algn="l"/>
+            <a:r>
+              <a:rPr sz="1300" b="0" i="0">
+                <a:solidFill>
+                  <a:srgbClr val="333333"/>
+                </a:solidFill>
+              </a:rPr>
+              <a:t>✅ Built — Slack pending</a:t>
+            </a:r>
+          </a:p>
+        </p:txBody>
+      </p:sp>
+      <p:sp>
+        <p:nvSpPr>
+          <p:cNvPr id="60" name="Rectangle 59"/>
+          <p:cNvSpPr/>
+          <p:nvPr/>
+        </p:nvSpPr>
+        <p:spPr>
+          <a:xfrm>
+            <a:off x="457200" y="5074920"/>
+            <a:ext cx="11247120" cy="1051560"/>
+          </a:xfrm>
+          <a:prstGeom prst="rect">
+            <a:avLst/>
+          </a:prstGeom>
+          <a:solidFill>
+            <a:srgbClr val="F7F9FC"/>
+          </a:solidFill>
+          <a:ln>
+            <a:noFill/>
+          </a:ln>
+        </p:spPr>
+        <p:style>
+          <a:lnRef idx="1">
+            <a:schemeClr val="accent1"/>
+          </a:lnRef>
+          <a:fillRef idx="3">
+            <a:schemeClr val="accent1"/>
+          </a:fillRef>
+          <a:effectRef idx="2">
+            <a:schemeClr val="accent1"/>
+          </a:effectRef>
+          <a:fontRef idx="minor">
+            <a:schemeClr val="lt1"/>
+          </a:fontRef>
+        </p:style>
+        <p:txBody>
+          <a:bodyPr rtlCol="0" anchor="ctr"/>
+          <a:lstStyle/>
+          <a:p>
+            <a:pPr algn="ctr"/>
+          </a:p>
+        </p:txBody>
+      </p:sp>
+      <p:sp>
+        <p:nvSpPr>
+          <p:cNvPr id="61" name="Rectangle 60"/>
+          <p:cNvSpPr/>
+          <p:nvPr/>
+        </p:nvSpPr>
+        <p:spPr>
+          <a:xfrm>
+            <a:off x="457200" y="5074920"/>
+            <a:ext cx="63500" cy="1051560"/>
+          </a:xfrm>
+          <a:prstGeom prst="rect">
+            <a:avLst/>
+          </a:prstGeom>
+          <a:solidFill>
+            <a:srgbClr val="E94560"/>
+          </a:solidFill>
+          <a:ln>
+            <a:noFill/>
+          </a:ln>
+        </p:spPr>
+        <p:style>
+          <a:lnRef idx="1">
+            <a:schemeClr val="accent1"/>
+          </a:lnRef>
+          <a:fillRef idx="3">
+            <a:schemeClr val="accent1"/>
+          </a:fillRef>
+          <a:effectRef idx="2">
+            <a:schemeClr val="accent1"/>
+          </a:effectRef>
+          <a:fontRef idx="minor">
+            <a:schemeClr val="lt1"/>
+          </a:fontRef>
+        </p:style>
+        <p:txBody>
+          <a:bodyPr rtlCol="0" anchor="ctr"/>
+          <a:lstStyle/>
+          <a:p>
+            <a:pPr algn="ctr"/>
+          </a:p>
+        </p:txBody>
+      </p:sp>
+      <p:sp>
+        <p:nvSpPr>
+          <p:cNvPr id="62" name="TextBox 61"/>
+          <p:cNvSpPr txBox="1"/>
+          <p:nvPr/>
+        </p:nvSpPr>
+        <p:spPr>
+          <a:xfrm>
+            <a:off x="685800" y="5138928"/>
+            <a:ext cx="10881360" cy="914400"/>
           </a:xfrm>
           <a:prstGeom prst="rect">
             <a:avLst/>
@@ -5448,7 +5756,7 @@
                   <a:srgbClr val="333333"/>
                 </a:solidFill>
               </a:rPr>
-              <a:t>All five phases are built, integrated, and running on Databricks. The POC uses generated retail data (sales transactions + event streams) designed to mirror real-world data patterns at scale.</a:t>
+              <a:t>All five phases and Stage A alerting are built and running on Databricks; the batch DAG and the streaming pipeline have been run end to end. The POC uses generated retail data (sales transactions + event streams) designed to mirror real-world data patterns at scale.</a:t>
             </a:r>
           </a:p>
         </p:txBody>
@@ -9226,7 +9534,19 @@
                 </a:solidFill>
                 <a:latin typeface="Courier New"/>
               </a:rPr>
-              <a:t>    if is_numeric and col_min is not None and col_min &gt; 0:</a:t>
+              <a:t>    # (skipped for code-like integers such as division / *_id)</a:t>
+            </a:r>
+          </a:p>
+          <a:p>
+            <a:pPr algn="l"/>
+            <a:r>
+              <a:rPr sz="1050">
+                <a:solidFill>
+                  <a:srgbClr val="CDD6F4"/>
+                </a:solidFill>
+                <a:latin typeface="Courier New"/>
+              </a:rPr>
+              <a:t>    if is_numeric and not _is_code_like(col_name, dtype) and col_min &gt; 0:</a:t>
             </a:r>
           </a:p>
           <a:p>
@@ -9798,7 +10118,7 @@
                 </a:solidFill>
                 <a:latin typeface="Courier New"/>
               </a:rPr>
-              <a:t>approve_rule(rule_id, spark)   # inserts into dq_rules_registry</a:t>
+              <a:t>promote_rule(rule_id, reviewed_by, spark)  # DQX-native names -&gt; dq_rules_registry</a:t>
             </a:r>
           </a:p>
           <a:p>
@@ -9810,7 +10130,31 @@
                 </a:solidFill>
                 <a:latin typeface="Courier New"/>
               </a:rPr>
-              <a:t>reject_rule(rule_id, spark)    # marks status='rejected', preserved for fine-tuning</a:t>
+              <a:t>reject_rule(rule_id, reviewed_by, spark)   # status='rejected', kept for fine-tuning</a:t>
+            </a:r>
+          </a:p>
+          <a:p>
+            <a:pPr algn="l"/>
+            <a:r>
+              <a:rPr sz="1050">
+                <a:solidFill>
+                  <a:srgbClr val="CDD6F4"/>
+                </a:solidFill>
+                <a:latin typeface="Courier New"/>
+              </a:rPr>
+              <a:t/>
+            </a:r>
+          </a:p>
+          <a:p>
+            <a:pPr algn="l"/>
+            <a:r>
+              <a:rPr sz="1050">
+                <a:solidFill>
+                  <a:srgbClr val="CDD6F4"/>
+                </a:solidFill>
+                <a:latin typeface="Courier New"/>
+              </a:rPr>
+              <a:t># On write: duplicates and names of live rules are skipped</a:t>
             </a:r>
           </a:p>
         </p:txBody>
@@ -9823,28 +10167,28 @@
         </p:nvSpPr>
         <p:spPr>
           <a:xfrm>
-            <a:off x="457200" y="6263640"/>
-            <a:ext cx="11247120" cy="365760"/>
-          </a:xfrm>
-          <a:prstGeom prst="rect">
-            <a:avLst/>
-          </a:prstGeom>
-          <a:noFill/>
-        </p:spPr>
-        <p:txBody>
-          <a:bodyPr wrap="square">
-            <a:spAutoFit/>
-          </a:bodyPr>
-          <a:lstStyle/>
-          <a:p>
-            <a:pPr algn="l"/>
-            <a:r>
-              <a:rPr sz="1400" b="1" i="0">
+            <a:off x="457200" y="6217920"/>
+            <a:ext cx="11247120" cy="548640"/>
+          </a:xfrm>
+          <a:prstGeom prst="rect">
+            <a:avLst/>
+          </a:prstGeom>
+          <a:noFill/>
+        </p:spPr>
+        <p:txBody>
+          <a:bodyPr wrap="square">
+            <a:spAutoFit/>
+          </a:bodyPr>
+          <a:lstStyle/>
+          <a:p>
+            <a:pPr algn="l"/>
+            <a:r>
+              <a:rPr sz="1300" b="1" i="0">
                 <a:solidFill>
                   <a:srgbClr val="0F3460"/>
                 </a:solidFill>
               </a:rPr>
-              <a:t>Full audit trail: rule_id · suggested_at · reviewed_at · reviewed_by · llm_backend</a:t>
+              <a:t>Audit trail: rule_id · suggested_at · reviewed_by · llm_backend   |   Duplicates skipped on write · DQX names applied on promotion</a:t>
             </a:r>
           </a:p>
         </p:txBody>
@@ -15773,7 +16117,7 @@
                   <a:srgbClr val="0F3460"/>
                 </a:solidFill>
               </a:rPr>
-              <a:t>DATABRICKS UNITY CATALOG  —  dqx_poc_cluster_7405619883480512 / retail_dqx_poc</a:t>
+              <a:t>DATABRICKS UNITY CATALOG  —  dqx_poc_dev / retail_dqx_poc</a:t>
             </a:r>
           </a:p>
         </p:txBody>
@@ -16852,7 +17196,7 @@
                 </a:solidFill>
                 <a:latin typeface="Courier New"/>
               </a:rPr>
-              <a:t>CATALOG  = 'dqx_poc_cluster_7405619883480512'</a:t>
+              <a:t>CATALOG  = 'dqx_poc_dev'</a:t>
             </a:r>
           </a:p>
           <a:p>
@@ -18917,7 +19261,7 @@
         <p:spPr>
           <a:xfrm>
             <a:off x="457200" y="1508760"/>
-            <a:ext cx="3840480" cy="384048"/>
+            <a:ext cx="3200400" cy="384048"/>
           </a:xfrm>
           <a:prstGeom prst="rect">
             <a:avLst/>
@@ -18960,7 +19304,7 @@
         <p:spPr>
           <a:xfrm>
             <a:off x="502920" y="1559560"/>
-            <a:ext cx="3749040" cy="384048"/>
+            <a:ext cx="3108960" cy="384048"/>
           </a:xfrm>
           <a:prstGeom prst="rect">
             <a:avLst/>
@@ -18993,8 +19337,8 @@
         </p:nvSpPr>
         <p:spPr>
           <a:xfrm>
-            <a:off x="4297680" y="1508760"/>
-            <a:ext cx="2560320" cy="384048"/>
+            <a:off x="3657600" y="1508760"/>
+            <a:ext cx="2743200" cy="384048"/>
           </a:xfrm>
           <a:prstGeom prst="rect">
             <a:avLst/>
@@ -19036,8 +19380,8 @@
         </p:nvSpPr>
         <p:spPr>
           <a:xfrm>
-            <a:off x="4343400" y="1559560"/>
-            <a:ext cx="2468880" cy="384048"/>
+            <a:off x="3703320" y="1559560"/>
+            <a:ext cx="2651760" cy="384048"/>
           </a:xfrm>
           <a:prstGeom prst="rect">
             <a:avLst/>
@@ -19070,8 +19414,8 @@
         </p:nvSpPr>
         <p:spPr>
           <a:xfrm>
-            <a:off x="6858000" y="1508760"/>
-            <a:ext cx="4846320" cy="384048"/>
+            <a:off x="6400800" y="1508760"/>
+            <a:ext cx="5303520" cy="384048"/>
           </a:xfrm>
           <a:prstGeom prst="rect">
             <a:avLst/>
@@ -19113,8 +19457,8 @@
         </p:nvSpPr>
         <p:spPr>
           <a:xfrm>
-            <a:off x="6903720" y="1559560"/>
-            <a:ext cx="4754880" cy="384048"/>
+            <a:off x="6446520" y="1559560"/>
+            <a:ext cx="5212080" cy="384048"/>
           </a:xfrm>
           <a:prstGeom prst="rect">
             <a:avLst/>
@@ -19134,7 +19478,7 @@
                   <a:srgbClr val="FFFFFF"/>
                 </a:solidFill>
               </a:rPr>
-              <a:t>Notebook / Script</a:t>
+              <a:t>Tasks</a:t>
             </a:r>
           </a:p>
         </p:txBody>
@@ -19148,7 +19492,7 @@
         <p:spPr>
           <a:xfrm>
             <a:off x="457200" y="1892808"/>
-            <a:ext cx="3840480" cy="347472"/>
+            <a:ext cx="3200400" cy="347472"/>
           </a:xfrm>
           <a:prstGeom prst="rect">
             <a:avLst/>
@@ -19191,27 +19535,27 @@
         <p:spPr>
           <a:xfrm>
             <a:off x="502920" y="1930908"/>
-            <a:ext cx="3749040" cy="347472"/>
-          </a:xfrm>
-          <a:prstGeom prst="rect">
-            <a:avLst/>
-          </a:prstGeom>
-          <a:noFill/>
-        </p:spPr>
-        <p:txBody>
-          <a:bodyPr wrap="square">
-            <a:spAutoFit/>
-          </a:bodyPr>
-          <a:lstStyle/>
-          <a:p>
-            <a:pPr algn="l"/>
-            <a:r>
-              <a:rPr sz="1300" b="0" i="0">
+            <a:ext cx="3108960" cy="347472"/>
+          </a:xfrm>
+          <a:prstGeom prst="rect">
+            <a:avLst/>
+          </a:prstGeom>
+          <a:noFill/>
+        </p:spPr>
+        <p:txBody>
+          <a:bodyPr wrap="square">
+            <a:spAutoFit/>
+          </a:bodyPr>
+          <a:lstStyle/>
+          <a:p>
+            <a:pPr algn="l"/>
+            <a:r>
+              <a:rPr sz="1200" b="0" i="0">
                 <a:solidFill>
                   <a:srgbClr val="333333"/>
                 </a:solidFill>
               </a:rPr>
-              <a:t>[RTM] Setup Delta Tables</a:t>
+              <a:t>[RTM] Seed Rules Registry</a:t>
             </a:r>
           </a:p>
         </p:txBody>
@@ -19224,8 +19568,8 @@
         </p:nvSpPr>
         <p:spPr>
           <a:xfrm>
-            <a:off x="4297680" y="1892808"/>
-            <a:ext cx="2560320" cy="347472"/>
+            <a:off x="3657600" y="1892808"/>
+            <a:ext cx="2743200" cy="347472"/>
           </a:xfrm>
           <a:prstGeom prst="rect">
             <a:avLst/>
@@ -19267,28 +19611,28 @@
         </p:nvSpPr>
         <p:spPr>
           <a:xfrm>
-            <a:off x="4343400" y="1930908"/>
-            <a:ext cx="2468880" cy="347472"/>
-          </a:xfrm>
-          <a:prstGeom prst="rect">
-            <a:avLst/>
-          </a:prstGeom>
-          <a:noFill/>
-        </p:spPr>
-        <p:txBody>
-          <a:bodyPr wrap="square">
-            <a:spAutoFit/>
-          </a:bodyPr>
-          <a:lstStyle/>
-          <a:p>
-            <a:pPr algn="l"/>
-            <a:r>
-              <a:rPr sz="1300" b="0" i="0">
+            <a:off x="3703320" y="1930908"/>
+            <a:ext cx="2651760" cy="347472"/>
+          </a:xfrm>
+          <a:prstGeom prst="rect">
+            <a:avLst/>
+          </a:prstGeom>
+          <a:noFill/>
+        </p:spPr>
+        <p:txBody>
+          <a:bodyPr wrap="square">
+            <a:spAutoFit/>
+          </a:bodyPr>
+          <a:lstStyle/>
+          <a:p>
+            <a:pPr algn="l"/>
+            <a:r>
+              <a:rPr sz="1200" b="0" i="0">
                 <a:solidFill>
                   <a:srgbClr val="333333"/>
                 </a:solidFill>
               </a:rPr>
-              <a:t>Once (infra)</a:t>
+              <a:t>Once per environment</a:t>
             </a:r>
           </a:p>
         </p:txBody>
@@ -19301,8 +19645,8 @@
         </p:nvSpPr>
         <p:spPr>
           <a:xfrm>
-            <a:off x="6858000" y="1892808"/>
-            <a:ext cx="4846320" cy="347472"/>
+            <a:off x="6400800" y="1892808"/>
+            <a:ext cx="5303520" cy="347472"/>
           </a:xfrm>
           <a:prstGeom prst="rect">
             <a:avLst/>
@@ -19344,28 +19688,28 @@
         </p:nvSpPr>
         <p:spPr>
           <a:xfrm>
-            <a:off x="6903720" y="1930908"/>
-            <a:ext cx="4754880" cy="347472"/>
-          </a:xfrm>
-          <a:prstGeom prst="rect">
-            <a:avLst/>
-          </a:prstGeom>
-          <a:noFill/>
-        </p:spPr>
-        <p:txBody>
-          <a:bodyPr wrap="square">
-            <a:spAutoFit/>
-          </a:bodyPr>
-          <a:lstStyle/>
-          <a:p>
-            <a:pPr algn="l"/>
-            <a:r>
-              <a:rPr sz="1300" b="0" i="0">
+            <a:off x="6446520" y="1930908"/>
+            <a:ext cx="5212080" cy="347472"/>
+          </a:xfrm>
+          <a:prstGeom prst="rect">
+            <a:avLst/>
+          </a:prstGeom>
+          <a:noFill/>
+        </p:spPr>
+        <p:txBody>
+          <a:bodyPr wrap="square">
+            <a:spAutoFit/>
+          </a:bodyPr>
+          <a:lstStyle/>
+          <a:p>
+            <a:pPr algn="l"/>
+            <a:r>
+              <a:rPr sz="1200" b="0" i="0">
                 <a:solidFill>
                   <a:srgbClr val="333333"/>
                 </a:solidFill>
               </a:rPr>
-              <a:t>notebooks/setup_delta_tables.py</a:t>
+              <a:t>seed_rules — loads configs/rules_*.yml into dq_rules_registry</a:t>
             </a:r>
           </a:p>
         </p:txBody>
@@ -19379,7 +19723,7 @@
         <p:spPr>
           <a:xfrm>
             <a:off x="457200" y="2240280"/>
-            <a:ext cx="3840480" cy="347472"/>
+            <a:ext cx="3200400" cy="347472"/>
           </a:xfrm>
           <a:prstGeom prst="rect">
             <a:avLst/>
@@ -19422,27 +19766,27 @@
         <p:spPr>
           <a:xfrm>
             <a:off x="502920" y="2278380"/>
-            <a:ext cx="3749040" cy="347472"/>
-          </a:xfrm>
-          <a:prstGeom prst="rect">
-            <a:avLst/>
-          </a:prstGeom>
-          <a:noFill/>
-        </p:spPr>
-        <p:txBody>
-          <a:bodyPr wrap="square">
-            <a:spAutoFit/>
-          </a:bodyPr>
-          <a:lstStyle/>
-          <a:p>
-            <a:pPr algn="l"/>
-            <a:r>
-              <a:rPr sz="1300" b="0" i="0">
+            <a:ext cx="3108960" cy="347472"/>
+          </a:xfrm>
+          <a:prstGeom prst="rect">
+            <a:avLst/>
+          </a:prstGeom>
+          <a:noFill/>
+        </p:spPr>
+        <p:txBody>
+          <a:bodyPr wrap="square">
+            <a:spAutoFit/>
+          </a:bodyPr>
+          <a:lstStyle/>
+          <a:p>
+            <a:pPr algn="l"/>
+            <a:r>
+              <a:rPr sz="1200" b="0" i="0">
                 <a:solidFill>
                   <a:srgbClr val="333333"/>
                 </a:solidFill>
               </a:rPr>
-              <a:t>[RTM] Batch DQX Validation</a:t>
+              <a:t>[RTM] Batch DQX Pipeline</a:t>
             </a:r>
           </a:p>
         </p:txBody>
@@ -19455,8 +19799,8 @@
         </p:nvSpPr>
         <p:spPr>
           <a:xfrm>
-            <a:off x="4297680" y="2240280"/>
-            <a:ext cx="2560320" cy="347472"/>
+            <a:off x="3657600" y="2240280"/>
+            <a:ext cx="2743200" cy="347472"/>
           </a:xfrm>
           <a:prstGeom prst="rect">
             <a:avLst/>
@@ -19498,28 +19842,28 @@
         </p:nvSpPr>
         <p:spPr>
           <a:xfrm>
-            <a:off x="4343400" y="2278380"/>
-            <a:ext cx="2468880" cy="347472"/>
-          </a:xfrm>
-          <a:prstGeom prst="rect">
-            <a:avLst/>
-          </a:prstGeom>
-          <a:noFill/>
-        </p:spPr>
-        <p:txBody>
-          <a:bodyPr wrap="square">
-            <a:spAutoFit/>
-          </a:bodyPr>
-          <a:lstStyle/>
-          <a:p>
-            <a:pPr algn="l"/>
-            <a:r>
-              <a:rPr sz="1300" b="0" i="0">
+            <a:off x="3703320" y="2278380"/>
+            <a:ext cx="2651760" cy="347472"/>
+          </a:xfrm>
+          <a:prstGeom prst="rect">
+            <a:avLst/>
+          </a:prstGeom>
+          <a:noFill/>
+        </p:spPr>
+        <p:txBody>
+          <a:bodyPr wrap="square">
+            <a:spAutoFit/>
+          </a:bodyPr>
+          <a:lstStyle/>
+          <a:p>
+            <a:pPr algn="l"/>
+            <a:r>
+              <a:rPr sz="1200" b="0" i="0">
                 <a:solidFill>
                   <a:srgbClr val="333333"/>
                 </a:solidFill>
               </a:rPr>
-              <a:t>Scheduled / on-demand</a:t>
+              <a:t>On-demand / scheduled</a:t>
             </a:r>
           </a:p>
         </p:txBody>
@@ -19532,8 +19876,8 @@
         </p:nvSpPr>
         <p:spPr>
           <a:xfrm>
-            <a:off x="6858000" y="2240280"/>
-            <a:ext cx="4846320" cy="347472"/>
+            <a:off x="6400800" y="2240280"/>
+            <a:ext cx="5303520" cy="347472"/>
           </a:xfrm>
           <a:prstGeom prst="rect">
             <a:avLst/>
@@ -19575,28 +19919,28 @@
         </p:nvSpPr>
         <p:spPr>
           <a:xfrm>
-            <a:off x="6903720" y="2278380"/>
-            <a:ext cx="4754880" cy="347472"/>
-          </a:xfrm>
-          <a:prstGeom prst="rect">
-            <a:avLst/>
-          </a:prstGeom>
-          <a:noFill/>
-        </p:spPr>
-        <p:txBody>
-          <a:bodyPr wrap="square">
-            <a:spAutoFit/>
-          </a:bodyPr>
-          <a:lstStyle/>
-          <a:p>
-            <a:pPr algn="l"/>
-            <a:r>
-              <a:rPr sz="1300" b="0" i="0">
+            <a:off x="6446520" y="2278380"/>
+            <a:ext cx="5212080" cy="347472"/>
+          </a:xfrm>
+          <a:prstGeom prst="rect">
+            <a:avLst/>
+          </a:prstGeom>
+          <a:noFill/>
+        </p:spPr>
+        <p:txBody>
+          <a:bodyPr wrap="square">
+            <a:spAutoFit/>
+          </a:bodyPr>
+          <a:lstStyle/>
+          <a:p>
+            <a:pPr algn="l"/>
+            <a:r>
+              <a:rPr sz="1200" b="0" i="0">
                 <a:solidFill>
                   <a:srgbClr val="333333"/>
                 </a:solidFill>
               </a:rPr>
-              <a:t>notebooks/batch_dqx_validation.py</a:t>
+              <a:t>6-task DAG: stage → validate → suggest ∥ analyze → report → alerts</a:t>
             </a:r>
           </a:p>
         </p:txBody>
@@ -19610,7 +19954,7 @@
         <p:spPr>
           <a:xfrm>
             <a:off x="457200" y="2587752"/>
-            <a:ext cx="3840480" cy="347472"/>
+            <a:ext cx="3200400" cy="347472"/>
           </a:xfrm>
           <a:prstGeom prst="rect">
             <a:avLst/>
@@ -19653,27 +19997,27 @@
         <p:spPr>
           <a:xfrm>
             <a:off x="502920" y="2625852"/>
-            <a:ext cx="3749040" cy="347472"/>
-          </a:xfrm>
-          <a:prstGeom prst="rect">
-            <a:avLst/>
-          </a:prstGeom>
-          <a:noFill/>
-        </p:spPr>
-        <p:txBody>
-          <a:bodyPr wrap="square">
-            <a:spAutoFit/>
-          </a:bodyPr>
-          <a:lstStyle/>
-          <a:p>
-            <a:pPr algn="l"/>
-            <a:r>
-              <a:rPr sz="1300" b="0" i="0">
+            <a:ext cx="3108960" cy="347472"/>
+          </a:xfrm>
+          <a:prstGeom prst="rect">
+            <a:avLst/>
+          </a:prstGeom>
+          <a:noFill/>
+        </p:spPr>
+        <p:txBody>
+          <a:bodyPr wrap="square">
+            <a:spAutoFit/>
+          </a:bodyPr>
+          <a:lstStyle/>
+          <a:p>
+            <a:pPr algn="l"/>
+            <a:r>
+              <a:rPr sz="1200" b="0" i="0">
                 <a:solidFill>
                   <a:srgbClr val="333333"/>
                 </a:solidFill>
               </a:rPr>
-              <a:t>[RTM] Kafka Stream DQX Validation</a:t>
+              <a:t>[RTM] Kafka Streaming Pipeline</a:t>
             </a:r>
           </a:p>
         </p:txBody>
@@ -19686,8 +20030,8 @@
         </p:nvSpPr>
         <p:spPr>
           <a:xfrm>
-            <a:off x="4297680" y="2587752"/>
-            <a:ext cx="2560320" cy="347472"/>
+            <a:off x="3657600" y="2587752"/>
+            <a:ext cx="2743200" cy="347472"/>
           </a:xfrm>
           <a:prstGeom prst="rect">
             <a:avLst/>
@@ -19729,28 +20073,28 @@
         </p:nvSpPr>
         <p:spPr>
           <a:xfrm>
-            <a:off x="4343400" y="2625852"/>
-            <a:ext cx="2468880" cy="347472"/>
-          </a:xfrm>
-          <a:prstGeom prst="rect">
-            <a:avLst/>
-          </a:prstGeom>
-          <a:noFill/>
-        </p:spPr>
-        <p:txBody>
-          <a:bodyPr wrap="square">
-            <a:spAutoFit/>
-          </a:bodyPr>
-          <a:lstStyle/>
-          <a:p>
-            <a:pPr algn="l"/>
-            <a:r>
-              <a:rPr sz="1300" b="0" i="0">
+            <a:off x="3703320" y="2625852"/>
+            <a:ext cx="2651760" cy="347472"/>
+          </a:xfrm>
+          <a:prstGeom prst="rect">
+            <a:avLst/>
+          </a:prstGeom>
+          <a:noFill/>
+        </p:spPr>
+        <p:txBody>
+          <a:bodyPr wrap="square">
+            <a:spAutoFit/>
+          </a:bodyPr>
+          <a:lstStyle/>
+          <a:p>
+            <a:pPr algn="l"/>
+            <a:r>
+              <a:rPr sz="1200" b="0" i="0">
                 <a:solidFill>
                   <a:srgbClr val="333333"/>
                 </a:solidFill>
               </a:rPr>
-              <a:t>Continuous</a:t>
+              <a:t>Continuous (runs until cancelled)</a:t>
             </a:r>
           </a:p>
         </p:txBody>
@@ -19763,8 +20107,8 @@
         </p:nvSpPr>
         <p:spPr>
           <a:xfrm>
-            <a:off x="6858000" y="2587752"/>
-            <a:ext cx="4846320" cy="347472"/>
+            <a:off x="6400800" y="2587752"/>
+            <a:ext cx="5303520" cy="347472"/>
           </a:xfrm>
           <a:prstGeom prst="rect">
             <a:avLst/>
@@ -19806,28 +20150,28 @@
         </p:nvSpPr>
         <p:spPr>
           <a:xfrm>
-            <a:off x="6903720" y="2625852"/>
-            <a:ext cx="4754880" cy="347472"/>
-          </a:xfrm>
-          <a:prstGeom prst="rect">
-            <a:avLst/>
-          </a:prstGeom>
-          <a:noFill/>
-        </p:spPr>
-        <p:txBody>
-          <a:bodyPr wrap="square">
-            <a:spAutoFit/>
-          </a:bodyPr>
-          <a:lstStyle/>
-          <a:p>
-            <a:pPr algn="l"/>
-            <a:r>
-              <a:rPr sz="1300" b="0" i="0">
+            <a:off x="6446520" y="2625852"/>
+            <a:ext cx="5212080" cy="347472"/>
+          </a:xfrm>
+          <a:prstGeom prst="rect">
+            <a:avLst/>
+          </a:prstGeom>
+          <a:noFill/>
+        </p:spPr>
+        <p:txBody>
+          <a:bodyPr wrap="square">
+            <a:spAutoFit/>
+          </a:bodyPr>
+          <a:lstStyle/>
+          <a:p>
+            <a:pPr algn="l"/>
+            <a:r>
+              <a:rPr sz="1200" b="0" i="0">
                 <a:solidFill>
                   <a:srgbClr val="333333"/>
                 </a:solidFill>
               </a:rPr>
-              <a:t>notebooks/kafka_stream_dqx_validation.py</a:t>
+              <a:t>stream_and_validate + produce_events, started together; readiness handshake</a:t>
             </a:r>
           </a:p>
         </p:txBody>
@@ -19841,7 +20185,7 @@
         <p:spPr>
           <a:xfrm>
             <a:off x="457200" y="2935224"/>
-            <a:ext cx="3840480" cy="347472"/>
+            <a:ext cx="3200400" cy="347472"/>
           </a:xfrm>
           <a:prstGeom prst="rect">
             <a:avLst/>
@@ -19884,27 +20228,27 @@
         <p:spPr>
           <a:xfrm>
             <a:off x="502920" y="2973324"/>
-            <a:ext cx="3749040" cy="347472"/>
-          </a:xfrm>
-          <a:prstGeom prst="rect">
-            <a:avLst/>
-          </a:prstGeom>
-          <a:noFill/>
-        </p:spPr>
-        <p:txBody>
-          <a:bodyPr wrap="square">
-            <a:spAutoFit/>
-          </a:bodyPr>
-          <a:lstStyle/>
-          <a:p>
-            <a:pPr algn="l"/>
-            <a:r>
-              <a:rPr sz="1300" b="0" i="0">
+            <a:ext cx="3108960" cy="347472"/>
+          </a:xfrm>
+          <a:prstGeom prst="rect">
+            <a:avLst/>
+          </a:prstGeom>
+          <a:noFill/>
+        </p:spPr>
+        <p:txBody>
+          <a:bodyPr wrap="square">
+            <a:spAutoFit/>
+          </a:bodyPr>
+          <a:lstStyle/>
+          <a:p>
+            <a:pPr algn="l"/>
+            <a:r>
+              <a:rPr sz="1200" b="0" i="0">
                 <a:solidFill>
                   <a:srgbClr val="333333"/>
                 </a:solidFill>
               </a:rPr>
-              <a:t>[RTM] AI Rule Suggester</a:t>
+              <a:t>[RTM] DQ Alert Check (Streaming)</a:t>
             </a:r>
           </a:p>
         </p:txBody>
@@ -19917,8 +20261,8 @@
         </p:nvSpPr>
         <p:spPr>
           <a:xfrm>
-            <a:off x="4297680" y="2935224"/>
-            <a:ext cx="2560320" cy="347472"/>
+            <a:off x="3657600" y="2935224"/>
+            <a:ext cx="2743200" cy="347472"/>
           </a:xfrm>
           <a:prstGeom prst="rect">
             <a:avLst/>
@@ -19960,28 +20304,28 @@
         </p:nvSpPr>
         <p:spPr>
           <a:xfrm>
-            <a:off x="4343400" y="2973324"/>
-            <a:ext cx="2468880" cy="347472"/>
-          </a:xfrm>
-          <a:prstGeom prst="rect">
-            <a:avLst/>
-          </a:prstGeom>
-          <a:noFill/>
-        </p:spPr>
-        <p:txBody>
-          <a:bodyPr wrap="square">
-            <a:spAutoFit/>
-          </a:bodyPr>
-          <a:lstStyle/>
-          <a:p>
-            <a:pPr algn="l"/>
-            <a:r>
-              <a:rPr sz="1300" b="0" i="0">
+            <a:off x="3703320" y="2973324"/>
+            <a:ext cx="2651760" cy="347472"/>
+          </a:xfrm>
+          <a:prstGeom prst="rect">
+            <a:avLst/>
+          </a:prstGeom>
+          <a:noFill/>
+        </p:spPr>
+        <p:txBody>
+          <a:bodyPr wrap="square">
+            <a:spAutoFit/>
+          </a:bodyPr>
+          <a:lstStyle/>
+          <a:p>
+            <a:pPr algn="l"/>
+            <a:r>
+              <a:rPr sz="1200" b="0" i="0">
                 <a:solidFill>
                   <a:srgbClr val="333333"/>
                 </a:solidFill>
               </a:rPr>
-              <a:t>On-demand</a:t>
+              <a:t>Every 15 minutes</a:t>
             </a:r>
           </a:p>
         </p:txBody>
@@ -19994,8 +20338,8 @@
         </p:nvSpPr>
         <p:spPr>
           <a:xfrm>
-            <a:off x="6858000" y="2935224"/>
-            <a:ext cx="4846320" cy="347472"/>
+            <a:off x="6400800" y="2935224"/>
+            <a:ext cx="5303520" cy="347472"/>
           </a:xfrm>
           <a:prstGeom prst="rect">
             <a:avLst/>
@@ -20037,28 +20381,28 @@
         </p:nvSpPr>
         <p:spPr>
           <a:xfrm>
-            <a:off x="6903720" y="2973324"/>
-            <a:ext cx="4754880" cy="347472"/>
-          </a:xfrm>
-          <a:prstGeom prst="rect">
-            <a:avLst/>
-          </a:prstGeom>
-          <a:noFill/>
-        </p:spPr>
-        <p:txBody>
-          <a:bodyPr wrap="square">
-            <a:spAutoFit/>
-          </a:bodyPr>
-          <a:lstStyle/>
-          <a:p>
-            <a:pPr algn="l"/>
-            <a:r>
-              <a:rPr sz="1300" b="0" i="0">
+            <a:off x="6446520" y="2973324"/>
+            <a:ext cx="5212080" cy="347472"/>
+          </a:xfrm>
+          <a:prstGeom prst="rect">
+            <a:avLst/>
+          </a:prstGeom>
+          <a:noFill/>
+        </p:spPr>
+        <p:txBody>
+          <a:bodyPr wrap="square">
+            <a:spAutoFit/>
+          </a:bodyPr>
+          <a:lstStyle/>
+          <a:p>
+            <a:pPr algn="l"/>
+            <a:r>
+              <a:rPr sz="1200" b="0" i="0">
                 <a:solidFill>
                   <a:srgbClr val="333333"/>
                 </a:solidFill>
               </a:rPr>
-              <a:t>notebooks/ai_rule_suggester.py</a:t>
+              <a:t>check_alerts — spike detection on streaming rules</a:t>
             </a:r>
           </a:p>
         </p:txBody>
@@ -20071,8 +20415,8 @@
         </p:nvSpPr>
         <p:spPr>
           <a:xfrm>
-            <a:off x="457200" y="3282696"/>
-            <a:ext cx="3840480" cy="347472"/>
+            <a:off x="457200" y="4983480"/>
+            <a:ext cx="11247120" cy="1371600"/>
           </a:xfrm>
           <a:prstGeom prst="rect">
             <a:avLst/>
@@ -20108,54 +20452,20 @@
       </p:sp>
       <p:sp>
         <p:nvSpPr>
-          <p:cNvPr id="35" name="TextBox 34"/>
-          <p:cNvSpPr txBox="1"/>
-          <p:nvPr/>
-        </p:nvSpPr>
-        <p:spPr>
-          <a:xfrm>
-            <a:off x="502920" y="3320796"/>
-            <a:ext cx="3749040" cy="347472"/>
-          </a:xfrm>
-          <a:prstGeom prst="rect">
-            <a:avLst/>
-          </a:prstGeom>
-          <a:noFill/>
-        </p:spPr>
-        <p:txBody>
-          <a:bodyPr wrap="square">
-            <a:spAutoFit/>
-          </a:bodyPr>
-          <a:lstStyle/>
-          <a:p>
-            <a:pPr algn="l"/>
-            <a:r>
-              <a:rPr sz="1300" b="0" i="0">
-                <a:solidFill>
-                  <a:srgbClr val="333333"/>
-                </a:solidFill>
-              </a:rPr>
-              <a:t>[RTM] Quarantine Analyzer</a:t>
-            </a:r>
-          </a:p>
-        </p:txBody>
-      </p:sp>
-      <p:sp>
-        <p:nvSpPr>
-          <p:cNvPr id="36" name="Rectangle 35"/>
-          <p:cNvSpPr/>
-          <p:nvPr/>
-        </p:nvSpPr>
-        <p:spPr>
-          <a:xfrm>
-            <a:off x="4297680" y="3282696"/>
-            <a:ext cx="2560320" cy="347472"/>
-          </a:xfrm>
-          <a:prstGeom prst="rect">
-            <a:avLst/>
-          </a:prstGeom>
-          <a:solidFill>
-            <a:srgbClr val="F7F9FC"/>
+          <p:cNvPr id="35" name="Rectangle 34"/>
+          <p:cNvSpPr/>
+          <p:nvPr/>
+        </p:nvSpPr>
+        <p:spPr>
+          <a:xfrm>
+            <a:off x="457200" y="4983480"/>
+            <a:ext cx="63500" cy="1371600"/>
+          </a:xfrm>
+          <a:prstGeom prst="rect">
+            <a:avLst/>
+          </a:prstGeom>
+          <a:solidFill>
+            <a:srgbClr val="E94560"/>
           </a:solidFill>
           <a:ln>
             <a:noFill/>
@@ -20185,462 +20495,34 @@
       </p:sp>
       <p:sp>
         <p:nvSpPr>
-          <p:cNvPr id="37" name="TextBox 36"/>
-          <p:cNvSpPr txBox="1"/>
-          <p:nvPr/>
-        </p:nvSpPr>
-        <p:spPr>
-          <a:xfrm>
-            <a:off x="4343400" y="3320796"/>
-            <a:ext cx="2468880" cy="347472"/>
-          </a:xfrm>
-          <a:prstGeom prst="rect">
-            <a:avLst/>
-          </a:prstGeom>
-          <a:noFill/>
-        </p:spPr>
-        <p:txBody>
-          <a:bodyPr wrap="square">
-            <a:spAutoFit/>
-          </a:bodyPr>
-          <a:lstStyle/>
-          <a:p>
-            <a:pPr algn="l"/>
-            <a:r>
-              <a:rPr sz="1300" b="0" i="0">
+          <p:cNvPr id="36" name="TextBox 35"/>
+          <p:cNvSpPr txBox="1"/>
+          <p:nvPr/>
+        </p:nvSpPr>
+        <p:spPr>
+          <a:xfrm>
+            <a:off x="685800" y="5074920"/>
+            <a:ext cx="10881360" cy="1188720"/>
+          </a:xfrm>
+          <a:prstGeom prst="rect">
+            <a:avLst/>
+          </a:prstGeom>
+          <a:noFill/>
+        </p:spPr>
+        <p:txBody>
+          <a:bodyPr wrap="square">
+            <a:spAutoFit/>
+          </a:bodyPr>
+          <a:lstStyle/>
+          <a:p>
+            <a:pPr algn="l"/>
+            <a:r>
+              <a:rPr sz="1400" b="0" i="1">
                 <a:solidFill>
                   <a:srgbClr val="333333"/>
                 </a:solidFill>
               </a:rPr>
-              <a:t>On-demand / scheduled</a:t>
-            </a:r>
-          </a:p>
-        </p:txBody>
-      </p:sp>
-      <p:sp>
-        <p:nvSpPr>
-          <p:cNvPr id="38" name="Rectangle 37"/>
-          <p:cNvSpPr/>
-          <p:nvPr/>
-        </p:nvSpPr>
-        <p:spPr>
-          <a:xfrm>
-            <a:off x="6858000" y="3282696"/>
-            <a:ext cx="4846320" cy="347472"/>
-          </a:xfrm>
-          <a:prstGeom prst="rect">
-            <a:avLst/>
-          </a:prstGeom>
-          <a:solidFill>
-            <a:srgbClr val="F7F9FC"/>
-          </a:solidFill>
-          <a:ln>
-            <a:noFill/>
-          </a:ln>
-        </p:spPr>
-        <p:style>
-          <a:lnRef idx="1">
-            <a:schemeClr val="accent1"/>
-          </a:lnRef>
-          <a:fillRef idx="3">
-            <a:schemeClr val="accent1"/>
-          </a:fillRef>
-          <a:effectRef idx="2">
-            <a:schemeClr val="accent1"/>
-          </a:effectRef>
-          <a:fontRef idx="minor">
-            <a:schemeClr val="lt1"/>
-          </a:fontRef>
-        </p:style>
-        <p:txBody>
-          <a:bodyPr rtlCol="0" anchor="ctr"/>
-          <a:lstStyle/>
-          <a:p>
-            <a:pPr algn="ctr"/>
-          </a:p>
-        </p:txBody>
-      </p:sp>
-      <p:sp>
-        <p:nvSpPr>
-          <p:cNvPr id="39" name="TextBox 38"/>
-          <p:cNvSpPr txBox="1"/>
-          <p:nvPr/>
-        </p:nvSpPr>
-        <p:spPr>
-          <a:xfrm>
-            <a:off x="6903720" y="3320796"/>
-            <a:ext cx="4754880" cy="347472"/>
-          </a:xfrm>
-          <a:prstGeom prst="rect">
-            <a:avLst/>
-          </a:prstGeom>
-          <a:noFill/>
-        </p:spPr>
-        <p:txBody>
-          <a:bodyPr wrap="square">
-            <a:spAutoFit/>
-          </a:bodyPr>
-          <a:lstStyle/>
-          <a:p>
-            <a:pPr algn="l"/>
-            <a:r>
-              <a:rPr sz="1300" b="0" i="0">
-                <a:solidFill>
-                  <a:srgbClr val="333333"/>
-                </a:solidFill>
-              </a:rPr>
-              <a:t>notebooks/quarantine_analyzer.py</a:t>
-            </a:r>
-          </a:p>
-        </p:txBody>
-      </p:sp>
-      <p:sp>
-        <p:nvSpPr>
-          <p:cNvPr id="40" name="Rectangle 39"/>
-          <p:cNvSpPr/>
-          <p:nvPr/>
-        </p:nvSpPr>
-        <p:spPr>
-          <a:xfrm>
-            <a:off x="457200" y="3630168"/>
-            <a:ext cx="3840480" cy="347472"/>
-          </a:xfrm>
-          <a:prstGeom prst="rect">
-            <a:avLst/>
-          </a:prstGeom>
-          <a:solidFill>
-            <a:srgbClr val="FFFFFF"/>
-          </a:solidFill>
-          <a:ln>
-            <a:noFill/>
-          </a:ln>
-        </p:spPr>
-        <p:style>
-          <a:lnRef idx="1">
-            <a:schemeClr val="accent1"/>
-          </a:lnRef>
-          <a:fillRef idx="3">
-            <a:schemeClr val="accent1"/>
-          </a:fillRef>
-          <a:effectRef idx="2">
-            <a:schemeClr val="accent1"/>
-          </a:effectRef>
-          <a:fontRef idx="minor">
-            <a:schemeClr val="lt1"/>
-          </a:fontRef>
-        </p:style>
-        <p:txBody>
-          <a:bodyPr rtlCol="0" anchor="ctr"/>
-          <a:lstStyle/>
-          <a:p>
-            <a:pPr algn="ctr"/>
-          </a:p>
-        </p:txBody>
-      </p:sp>
-      <p:sp>
-        <p:nvSpPr>
-          <p:cNvPr id="41" name="TextBox 40"/>
-          <p:cNvSpPr txBox="1"/>
-          <p:nvPr/>
-        </p:nvSpPr>
-        <p:spPr>
-          <a:xfrm>
-            <a:off x="502920" y="3668268"/>
-            <a:ext cx="3749040" cy="347472"/>
-          </a:xfrm>
-          <a:prstGeom prst="rect">
-            <a:avLst/>
-          </a:prstGeom>
-          <a:noFill/>
-        </p:spPr>
-        <p:txBody>
-          <a:bodyPr wrap="square">
-            <a:spAutoFit/>
-          </a:bodyPr>
-          <a:lstStyle/>
-          <a:p>
-            <a:pPr algn="l"/>
-            <a:r>
-              <a:rPr sz="1300" b="0" i="0">
-                <a:solidFill>
-                  <a:srgbClr val="333333"/>
-                </a:solidFill>
-              </a:rPr>
-              <a:t>[RTM] Rule Effectiveness Report</a:t>
-            </a:r>
-          </a:p>
-        </p:txBody>
-      </p:sp>
-      <p:sp>
-        <p:nvSpPr>
-          <p:cNvPr id="42" name="Rectangle 41"/>
-          <p:cNvSpPr/>
-          <p:nvPr/>
-        </p:nvSpPr>
-        <p:spPr>
-          <a:xfrm>
-            <a:off x="4297680" y="3630168"/>
-            <a:ext cx="2560320" cy="347472"/>
-          </a:xfrm>
-          <a:prstGeom prst="rect">
-            <a:avLst/>
-          </a:prstGeom>
-          <a:solidFill>
-            <a:srgbClr val="FFFFFF"/>
-          </a:solidFill>
-          <a:ln>
-            <a:noFill/>
-          </a:ln>
-        </p:spPr>
-        <p:style>
-          <a:lnRef idx="1">
-            <a:schemeClr val="accent1"/>
-          </a:lnRef>
-          <a:fillRef idx="3">
-            <a:schemeClr val="accent1"/>
-          </a:fillRef>
-          <a:effectRef idx="2">
-            <a:schemeClr val="accent1"/>
-          </a:effectRef>
-          <a:fontRef idx="minor">
-            <a:schemeClr val="lt1"/>
-          </a:fontRef>
-        </p:style>
-        <p:txBody>
-          <a:bodyPr rtlCol="0" anchor="ctr"/>
-          <a:lstStyle/>
-          <a:p>
-            <a:pPr algn="ctr"/>
-          </a:p>
-        </p:txBody>
-      </p:sp>
-      <p:sp>
-        <p:nvSpPr>
-          <p:cNvPr id="43" name="TextBox 42"/>
-          <p:cNvSpPr txBox="1"/>
-          <p:nvPr/>
-        </p:nvSpPr>
-        <p:spPr>
-          <a:xfrm>
-            <a:off x="4343400" y="3668268"/>
-            <a:ext cx="2468880" cy="347472"/>
-          </a:xfrm>
-          <a:prstGeom prst="rect">
-            <a:avLst/>
-          </a:prstGeom>
-          <a:noFill/>
-        </p:spPr>
-        <p:txBody>
-          <a:bodyPr wrap="square">
-            <a:spAutoFit/>
-          </a:bodyPr>
-          <a:lstStyle/>
-          <a:p>
-            <a:pPr algn="l"/>
-            <a:r>
-              <a:rPr sz="1300" b="0" i="0">
-                <a:solidFill>
-                  <a:srgbClr val="333333"/>
-                </a:solidFill>
-              </a:rPr>
-              <a:t>On-demand / scheduled</a:t>
-            </a:r>
-          </a:p>
-        </p:txBody>
-      </p:sp>
-      <p:sp>
-        <p:nvSpPr>
-          <p:cNvPr id="44" name="Rectangle 43"/>
-          <p:cNvSpPr/>
-          <p:nvPr/>
-        </p:nvSpPr>
-        <p:spPr>
-          <a:xfrm>
-            <a:off x="6858000" y="3630168"/>
-            <a:ext cx="4846320" cy="347472"/>
-          </a:xfrm>
-          <a:prstGeom prst="rect">
-            <a:avLst/>
-          </a:prstGeom>
-          <a:solidFill>
-            <a:srgbClr val="FFFFFF"/>
-          </a:solidFill>
-          <a:ln>
-            <a:noFill/>
-          </a:ln>
-        </p:spPr>
-        <p:style>
-          <a:lnRef idx="1">
-            <a:schemeClr val="accent1"/>
-          </a:lnRef>
-          <a:fillRef idx="3">
-            <a:schemeClr val="accent1"/>
-          </a:fillRef>
-          <a:effectRef idx="2">
-            <a:schemeClr val="accent1"/>
-          </a:effectRef>
-          <a:fontRef idx="minor">
-            <a:schemeClr val="lt1"/>
-          </a:fontRef>
-        </p:style>
-        <p:txBody>
-          <a:bodyPr rtlCol="0" anchor="ctr"/>
-          <a:lstStyle/>
-          <a:p>
-            <a:pPr algn="ctr"/>
-          </a:p>
-        </p:txBody>
-      </p:sp>
-      <p:sp>
-        <p:nvSpPr>
-          <p:cNvPr id="45" name="TextBox 44"/>
-          <p:cNvSpPr txBox="1"/>
-          <p:nvPr/>
-        </p:nvSpPr>
-        <p:spPr>
-          <a:xfrm>
-            <a:off x="6903720" y="3668268"/>
-            <a:ext cx="4754880" cy="347472"/>
-          </a:xfrm>
-          <a:prstGeom prst="rect">
-            <a:avLst/>
-          </a:prstGeom>
-          <a:noFill/>
-        </p:spPr>
-        <p:txBody>
-          <a:bodyPr wrap="square">
-            <a:spAutoFit/>
-          </a:bodyPr>
-          <a:lstStyle/>
-          <a:p>
-            <a:pPr algn="l"/>
-            <a:r>
-              <a:rPr sz="1300" b="0" i="0">
-                <a:solidFill>
-                  <a:srgbClr val="333333"/>
-                </a:solidFill>
-              </a:rPr>
-              <a:t>notebooks/rule_effectiveness_report.py</a:t>
-            </a:r>
-          </a:p>
-        </p:txBody>
-      </p:sp>
-      <p:sp>
-        <p:nvSpPr>
-          <p:cNvPr id="46" name="Rectangle 45"/>
-          <p:cNvSpPr/>
-          <p:nvPr/>
-        </p:nvSpPr>
-        <p:spPr>
-          <a:xfrm>
-            <a:off x="457200" y="4983480"/>
-            <a:ext cx="11247120" cy="914400"/>
-          </a:xfrm>
-          <a:prstGeom prst="rect">
-            <a:avLst/>
-          </a:prstGeom>
-          <a:solidFill>
-            <a:srgbClr val="F7F9FC"/>
-          </a:solidFill>
-          <a:ln>
-            <a:noFill/>
-          </a:ln>
-        </p:spPr>
-        <p:style>
-          <a:lnRef idx="1">
-            <a:schemeClr val="accent1"/>
-          </a:lnRef>
-          <a:fillRef idx="3">
-            <a:schemeClr val="accent1"/>
-          </a:fillRef>
-          <a:effectRef idx="2">
-            <a:schemeClr val="accent1"/>
-          </a:effectRef>
-          <a:fontRef idx="minor">
-            <a:schemeClr val="lt1"/>
-          </a:fontRef>
-        </p:style>
-        <p:txBody>
-          <a:bodyPr rtlCol="0" anchor="ctr"/>
-          <a:lstStyle/>
-          <a:p>
-            <a:pPr algn="ctr"/>
-          </a:p>
-        </p:txBody>
-      </p:sp>
-      <p:sp>
-        <p:nvSpPr>
-          <p:cNvPr id="47" name="Rectangle 46"/>
-          <p:cNvSpPr/>
-          <p:nvPr/>
-        </p:nvSpPr>
-        <p:spPr>
-          <a:xfrm>
-            <a:off x="457200" y="4983480"/>
-            <a:ext cx="63500" cy="914400"/>
-          </a:xfrm>
-          <a:prstGeom prst="rect">
-            <a:avLst/>
-          </a:prstGeom>
-          <a:solidFill>
-            <a:srgbClr val="E94560"/>
-          </a:solidFill>
-          <a:ln>
-            <a:noFill/>
-          </a:ln>
-        </p:spPr>
-        <p:style>
-          <a:lnRef idx="1">
-            <a:schemeClr val="accent1"/>
-          </a:lnRef>
-          <a:fillRef idx="3">
-            <a:schemeClr val="accent1"/>
-          </a:fillRef>
-          <a:effectRef idx="2">
-            <a:schemeClr val="accent1"/>
-          </a:effectRef>
-          <a:fontRef idx="minor">
-            <a:schemeClr val="lt1"/>
-          </a:fontRef>
-        </p:style>
-        <p:txBody>
-          <a:bodyPr rtlCol="0" anchor="ctr"/>
-          <a:lstStyle/>
-          <a:p>
-            <a:pPr algn="ctr"/>
-          </a:p>
-        </p:txBody>
-      </p:sp>
-      <p:sp>
-        <p:nvSpPr>
-          <p:cNvPr id="48" name="TextBox 47"/>
-          <p:cNvSpPr txBox="1"/>
-          <p:nvPr/>
-        </p:nvSpPr>
-        <p:spPr>
-          <a:xfrm>
-            <a:off x="685800" y="5074920"/>
-            <a:ext cx="10881360" cy="777240"/>
-          </a:xfrm>
-          <a:prstGeom prst="rect">
-            <a:avLst/>
-          </a:prstGeom>
-          <a:noFill/>
-        </p:spPr>
-        <p:txBody>
-          <a:bodyPr wrap="square">
-            <a:spAutoFit/>
-          </a:bodyPr>
-          <a:lstStyle/>
-          <a:p>
-            <a:pPr algn="l"/>
-            <a:r>
-              <a:rPr sz="1400" b="0" i="1">
-                <a:solidFill>
-                  <a:srgbClr val="333333"/>
-                </a:solidFill>
-              </a:rPr>
-              <a:t>All jobs defined in databricks.yml as a Databricks Asset Bundle — infrastructure as code, deployable across dev / staging / prod with a single CLI command: databricks bundle deploy</a:t>
+              <a:t>Six manually triggered jobs were chained into four orchestrated ones. All are defined in databricks.yml as a Databricks Asset Bundle, including the cluster libraries (pipeline_libraries), so a new environment needs no manual setup: databricks bundle deploy</a:t>
             </a:r>
           </a:p>
         </p:txBody>
@@ -21797,7 +21679,7 @@
                   <a:srgbClr val="333333"/>
                 </a:solidFill>
               </a:rPr>
-              <a:t>~15 seeded + AI-suggested</a:t>
+              <a:t>12 seeded + AI-suggested</a:t>
             </a:r>
           </a:p>
         </p:txBody>
@@ -22490,7 +22372,7 @@
                   <a:srgbClr val="333333"/>
                 </a:solidFill>
               </a:rPr>
-              <a:t>Databricks Secrets</a:t>
+              <a:t>Secret scope backed by Azure Key Vault</a:t>
             </a:r>
           </a:p>
         </p:txBody>
@@ -22567,7 +22449,7 @@
                   <a:srgbClr val="333333"/>
                 </a:solidFill>
               </a:rPr>
-              <a:t>Enterprise key vault (Azure Key Vault / HashiCorp)</a:t>
+              <a:t>Managed identities, rotation policies, per-environment vaults</a:t>
             </a:r>
           </a:p>
         </p:txBody>
@@ -23742,7 +23624,7 @@
                   <a:srgbClr val="333333"/>
                 </a:solidFill>
               </a:rPr>
-              <a:t>The LLM produced structurally valid, business-relevant rules from a column profile — no domain hints given. Rules were immediately executable by DQX with zero manual editing.</a:t>
+              <a:t>The LLM produced structurally valid, business-relevant rules from a column profile — no domain hints given. A built-in translation maps them to DQX-native names on promotion, so approved rules run without manual editing.</a:t>
             </a:r>
           </a:p>
         </p:txBody>
@@ -23755,7 +23637,7 @@
         </p:nvSpPr>
         <p:spPr>
           <a:xfrm>
-            <a:off x="548640" y="2258568"/>
+            <a:off x="548640" y="2350008"/>
             <a:ext cx="11064240" cy="320040"/>
           </a:xfrm>
           <a:prstGeom prst="rect">
@@ -23789,7 +23671,7 @@
         </p:nvSpPr>
         <p:spPr>
           <a:xfrm>
-            <a:off x="822960" y="2560320"/>
+            <a:off x="822960" y="2651760"/>
             <a:ext cx="10789920" cy="320040"/>
           </a:xfrm>
           <a:prstGeom prst="rect">
@@ -23823,7 +23705,7 @@
         </p:nvSpPr>
         <p:spPr>
           <a:xfrm>
-            <a:off x="548640" y="3008376"/>
+            <a:off x="548640" y="3191256"/>
             <a:ext cx="11064240" cy="320040"/>
           </a:xfrm>
           <a:prstGeom prst="rect">
@@ -23857,7 +23739,7 @@
         </p:nvSpPr>
         <p:spPr>
           <a:xfrm>
-            <a:off x="822960" y="3310128"/>
+            <a:off x="822960" y="3493008"/>
             <a:ext cx="10789920" cy="320040"/>
           </a:xfrm>
           <a:prstGeom prst="rect">
@@ -23891,7 +23773,7 @@
         </p:nvSpPr>
         <p:spPr>
           <a:xfrm>
-            <a:off x="548640" y="3758184"/>
+            <a:off x="548640" y="4032504"/>
             <a:ext cx="11064240" cy="320040"/>
           </a:xfrm>
           <a:prstGeom prst="rect">
@@ -23925,7 +23807,7 @@
         </p:nvSpPr>
         <p:spPr>
           <a:xfrm>
-            <a:off x="822960" y="4059936"/>
+            <a:off x="822960" y="4334256"/>
             <a:ext cx="10789920" cy="320040"/>
           </a:xfrm>
           <a:prstGeom prst="rect">
@@ -23959,7 +23841,7 @@
         </p:nvSpPr>
         <p:spPr>
           <a:xfrm>
-            <a:off x="548640" y="4507992"/>
+            <a:off x="548640" y="4873752"/>
             <a:ext cx="11064240" cy="320040"/>
           </a:xfrm>
           <a:prstGeom prst="rect">
@@ -23993,7 +23875,7 @@
         </p:nvSpPr>
         <p:spPr>
           <a:xfrm>
-            <a:off x="822960" y="4809744"/>
+            <a:off x="822960" y="5175504"/>
             <a:ext cx="10789920" cy="320040"/>
           </a:xfrm>
           <a:prstGeom prst="rect">
@@ -24143,7 +24025,7 @@
                   <a:srgbClr val="0F3460"/>
                 </a:solidFill>
               </a:rPr>
-              <a:t>48 unit tests across 4 files — all passing locally, no Spark cluster required:</a:t>
+              <a:t>105 unit tests across 9 files — 95 run without Spark; the 10 profiler tests need a local Spark session:</a:t>
             </a:r>
           </a:p>
         </p:txBody>
@@ -24156,7 +24038,7 @@
         </p:nvSpPr>
         <p:spPr>
           <a:xfrm>
-            <a:off x="457200" y="1920240"/>
+            <a:off x="457200" y="1874519"/>
             <a:ext cx="3840480" cy="384048"/>
           </a:xfrm>
           <a:prstGeom prst="rect">
@@ -24199,7 +24081,7 @@
         </p:nvSpPr>
         <p:spPr>
           <a:xfrm>
-            <a:off x="502920" y="1971040"/>
+            <a:off x="502920" y="1925319"/>
             <a:ext cx="3749040" cy="384048"/>
           </a:xfrm>
           <a:prstGeom prst="rect">
@@ -24215,7 +24097,7 @@
           <a:p>
             <a:pPr algn="l"/>
             <a:r>
-              <a:rPr sz="1400" b="1" i="0">
+              <a:rPr sz="1100" b="1" i="0">
                 <a:solidFill>
                   <a:srgbClr val="FFFFFF"/>
                 </a:solidFill>
@@ -24233,8 +24115,8 @@
         </p:nvSpPr>
         <p:spPr>
           <a:xfrm>
-            <a:off x="4297680" y="1920240"/>
-            <a:ext cx="1005840" cy="384048"/>
+            <a:off x="4297680" y="1874519"/>
+            <a:ext cx="914400" cy="384048"/>
           </a:xfrm>
           <a:prstGeom prst="rect">
             <a:avLst/>
@@ -24276,23 +24158,23 @@
         </p:nvSpPr>
         <p:spPr>
           <a:xfrm>
-            <a:off x="4343400" y="1971040"/>
-            <a:ext cx="914400" cy="384048"/>
-          </a:xfrm>
-          <a:prstGeom prst="rect">
-            <a:avLst/>
-          </a:prstGeom>
-          <a:noFill/>
-        </p:spPr>
-        <p:txBody>
-          <a:bodyPr wrap="square">
-            <a:spAutoFit/>
-          </a:bodyPr>
-          <a:lstStyle/>
-          <a:p>
-            <a:pPr algn="l"/>
-            <a:r>
-              <a:rPr sz="1400" b="1" i="0">
+            <a:off x="4343400" y="1925319"/>
+            <a:ext cx="822960" cy="384048"/>
+          </a:xfrm>
+          <a:prstGeom prst="rect">
+            <a:avLst/>
+          </a:prstGeom>
+          <a:noFill/>
+        </p:spPr>
+        <p:txBody>
+          <a:bodyPr wrap="square">
+            <a:spAutoFit/>
+          </a:bodyPr>
+          <a:lstStyle/>
+          <a:p>
+            <a:pPr algn="l"/>
+            <a:r>
+              <a:rPr sz="1100" b="1" i="0">
                 <a:solidFill>
                   <a:srgbClr val="FFFFFF"/>
                 </a:solidFill>
@@ -24310,8 +24192,8 @@
         </p:nvSpPr>
         <p:spPr>
           <a:xfrm>
-            <a:off x="5303520" y="1920240"/>
-            <a:ext cx="6400800" cy="384048"/>
+            <a:off x="5212080" y="1874519"/>
+            <a:ext cx="6492240" cy="384048"/>
           </a:xfrm>
           <a:prstGeom prst="rect">
             <a:avLst/>
@@ -24353,23 +24235,23 @@
         </p:nvSpPr>
         <p:spPr>
           <a:xfrm>
-            <a:off x="5349240" y="1971040"/>
-            <a:ext cx="6309360" cy="384048"/>
-          </a:xfrm>
-          <a:prstGeom prst="rect">
-            <a:avLst/>
-          </a:prstGeom>
-          <a:noFill/>
-        </p:spPr>
-        <p:txBody>
-          <a:bodyPr wrap="square">
-            <a:spAutoFit/>
-          </a:bodyPr>
-          <a:lstStyle/>
-          <a:p>
-            <a:pPr algn="l"/>
-            <a:r>
-              <a:rPr sz="1400" b="1" i="0">
+            <a:off x="5257800" y="1925319"/>
+            <a:ext cx="6400800" cy="384048"/>
+          </a:xfrm>
+          <a:prstGeom prst="rect">
+            <a:avLst/>
+          </a:prstGeom>
+          <a:noFill/>
+        </p:spPr>
+        <p:txBody>
+          <a:bodyPr wrap="square">
+            <a:spAutoFit/>
+          </a:bodyPr>
+          <a:lstStyle/>
+          <a:p>
+            <a:pPr algn="l"/>
+            <a:r>
+              <a:rPr sz="1100" b="1" i="0">
                 <a:solidFill>
                   <a:srgbClr val="FFFFFF"/>
                 </a:solidFill>
@@ -24387,7 +24269,7 @@
         </p:nvSpPr>
         <p:spPr>
           <a:xfrm>
-            <a:off x="457200" y="2304288"/>
+            <a:off x="457200" y="2258567"/>
             <a:ext cx="3840480" cy="347472"/>
           </a:xfrm>
           <a:prstGeom prst="rect">
@@ -24430,7 +24312,7 @@
         </p:nvSpPr>
         <p:spPr>
           <a:xfrm>
-            <a:off x="502920" y="2342388"/>
+            <a:off x="502920" y="2296667"/>
             <a:ext cx="3749040" cy="347472"/>
           </a:xfrm>
           <a:prstGeom prst="rect">
@@ -24446,7 +24328,7 @@
           <a:p>
             <a:pPr algn="l"/>
             <a:r>
-              <a:rPr sz="1300" b="0" i="0">
+              <a:rPr sz="1050" b="0" i="0">
                 <a:solidFill>
                   <a:srgbClr val="333333"/>
                 </a:solidFill>
@@ -24464,8 +24346,8 @@
         </p:nvSpPr>
         <p:spPr>
           <a:xfrm>
-            <a:off x="4297680" y="2304288"/>
-            <a:ext cx="1005840" cy="347472"/>
+            <a:off x="4297680" y="2258567"/>
+            <a:ext cx="914400" cy="347472"/>
           </a:xfrm>
           <a:prstGeom prst="rect">
             <a:avLst/>
@@ -24507,28 +24389,28 @@
         </p:nvSpPr>
         <p:spPr>
           <a:xfrm>
-            <a:off x="4343400" y="2342388"/>
-            <a:ext cx="914400" cy="347472"/>
-          </a:xfrm>
-          <a:prstGeom prst="rect">
-            <a:avLst/>
-          </a:prstGeom>
-          <a:noFill/>
-        </p:spPr>
-        <p:txBody>
-          <a:bodyPr wrap="square">
-            <a:spAutoFit/>
-          </a:bodyPr>
-          <a:lstStyle/>
-          <a:p>
-            <a:pPr algn="l"/>
-            <a:r>
-              <a:rPr sz="1300" b="0" i="0">
+            <a:off x="4343400" y="2296667"/>
+            <a:ext cx="822960" cy="347472"/>
+          </a:xfrm>
+          <a:prstGeom prst="rect">
+            <a:avLst/>
+          </a:prstGeom>
+          <a:noFill/>
+        </p:spPr>
+        <p:txBody>
+          <a:bodyPr wrap="square">
+            <a:spAutoFit/>
+          </a:bodyPr>
+          <a:lstStyle/>
+          <a:p>
+            <a:pPr algn="l"/>
+            <a:r>
+              <a:rPr sz="1050" b="0" i="0">
                 <a:solidFill>
                   <a:srgbClr val="333333"/>
                 </a:solidFill>
               </a:rPr>
-              <a:t>12</a:t>
+              <a:t>10</a:t>
             </a:r>
           </a:p>
         </p:txBody>
@@ -24541,8 +24423,8 @@
         </p:nvSpPr>
         <p:spPr>
           <a:xfrm>
-            <a:off x="5303520" y="2304288"/>
-            <a:ext cx="6400800" cy="347472"/>
+            <a:off x="5212080" y="2258567"/>
+            <a:ext cx="6492240" cy="347472"/>
           </a:xfrm>
           <a:prstGeom prst="rect">
             <a:avLst/>
@@ -24584,28 +24466,28 @@
         </p:nvSpPr>
         <p:spPr>
           <a:xfrm>
-            <a:off x="5349240" y="2342388"/>
-            <a:ext cx="6309360" cy="347472"/>
-          </a:xfrm>
-          <a:prstGeom prst="rect">
-            <a:avLst/>
-          </a:prstGeom>
-          <a:noFill/>
-        </p:spPr>
-        <p:txBody>
-          <a:bodyPr wrap="square">
-            <a:spAutoFit/>
-          </a:bodyPr>
-          <a:lstStyle/>
-          <a:p>
-            <a:pPr algn="l"/>
-            <a:r>
-              <a:rPr sz="1300" b="0" i="0">
+            <a:off x="5257800" y="2296667"/>
+            <a:ext cx="6400800" cy="347472"/>
+          </a:xfrm>
+          <a:prstGeom prst="rect">
+            <a:avLst/>
+          </a:prstGeom>
+          <a:noFill/>
+        </p:spPr>
+        <p:txBody>
+          <a:bodyPr wrap="square">
+            <a:spAutoFit/>
+          </a:bodyPr>
+          <a:lstStyle/>
+          <a:p>
+            <a:pPr algn="l"/>
+            <a:r>
+              <a:rPr sz="1050" b="0" i="0">
                 <a:solidFill>
                   <a:srgbClr val="333333"/>
                 </a:solidFill>
               </a:rPr>
-              <a:t>Column statistics, null detection, distribution analysis</a:t>
+              <a:t>Column statistics, null detection, distinct values (local Spark)</a:t>
             </a:r>
           </a:p>
         </p:txBody>
@@ -24618,7 +24500,7 @@
         </p:nvSpPr>
         <p:spPr>
           <a:xfrm>
-            <a:off x="457200" y="2651760"/>
+            <a:off x="457200" y="2606039"/>
             <a:ext cx="3840480" cy="347472"/>
           </a:xfrm>
           <a:prstGeom prst="rect">
@@ -24661,7 +24543,7 @@
         </p:nvSpPr>
         <p:spPr>
           <a:xfrm>
-            <a:off x="502920" y="2689860"/>
+            <a:off x="502920" y="2644139"/>
             <a:ext cx="3749040" cy="347472"/>
           </a:xfrm>
           <a:prstGeom prst="rect">
@@ -24677,7 +24559,7 @@
           <a:p>
             <a:pPr algn="l"/>
             <a:r>
-              <a:rPr sz="1300" b="0" i="0">
+              <a:rPr sz="1050" b="0" i="0">
                 <a:solidFill>
                   <a:srgbClr val="333333"/>
                 </a:solidFill>
@@ -24695,8 +24577,8 @@
         </p:nvSpPr>
         <p:spPr>
           <a:xfrm>
-            <a:off x="4297680" y="2651760"/>
-            <a:ext cx="1005840" cy="347472"/>
+            <a:off x="4297680" y="2606039"/>
+            <a:ext cx="914400" cy="347472"/>
           </a:xfrm>
           <a:prstGeom prst="rect">
             <a:avLst/>
@@ -24738,28 +24620,28 @@
         </p:nvSpPr>
         <p:spPr>
           <a:xfrm>
-            <a:off x="4343400" y="2689860"/>
-            <a:ext cx="914400" cy="347472"/>
-          </a:xfrm>
-          <a:prstGeom prst="rect">
-            <a:avLst/>
-          </a:prstGeom>
-          <a:noFill/>
-        </p:spPr>
-        <p:txBody>
-          <a:bodyPr wrap="square">
-            <a:spAutoFit/>
-          </a:bodyPr>
-          <a:lstStyle/>
-          <a:p>
-            <a:pPr algn="l"/>
-            <a:r>
-              <a:rPr sz="1300" b="0" i="0">
+            <a:off x="4343400" y="2644139"/>
+            <a:ext cx="822960" cy="347472"/>
+          </a:xfrm>
+          <a:prstGeom prst="rect">
+            <a:avLst/>
+          </a:prstGeom>
+          <a:noFill/>
+        </p:spPr>
+        <p:txBody>
+          <a:bodyPr wrap="square">
+            <a:spAutoFit/>
+          </a:bodyPr>
+          <a:lstStyle/>
+          <a:p>
+            <a:pPr algn="l"/>
+            <a:r>
+              <a:rPr sz="1050" b="0" i="0">
                 <a:solidFill>
                   <a:srgbClr val="333333"/>
                 </a:solidFill>
               </a:rPr>
-              <a:t>18</a:t>
+              <a:t>25</a:t>
             </a:r>
           </a:p>
         </p:txBody>
@@ -24772,8 +24654,8 @@
         </p:nvSpPr>
         <p:spPr>
           <a:xfrm>
-            <a:off x="5303520" y="2651760"/>
-            <a:ext cx="6400800" cy="347472"/>
+            <a:off x="5212080" y="2606039"/>
+            <a:ext cx="6492240" cy="347472"/>
           </a:xfrm>
           <a:prstGeom prst="rect">
             <a:avLst/>
@@ -24815,28 +24697,28 @@
         </p:nvSpPr>
         <p:spPr>
           <a:xfrm>
-            <a:off x="5349240" y="2689860"/>
-            <a:ext cx="6309360" cy="347472"/>
-          </a:xfrm>
-          <a:prstGeom prst="rect">
-            <a:avLst/>
-          </a:prstGeom>
-          <a:noFill/>
-        </p:spPr>
-        <p:txBody>
-          <a:bodyPr wrap="square">
-            <a:spAutoFit/>
-          </a:bodyPr>
-          <a:lstStyle/>
-          <a:p>
-            <a:pPr algn="l"/>
-            <a:r>
-              <a:rPr sz="1300" b="0" i="0">
+            <a:off x="5257800" y="2644139"/>
+            <a:ext cx="6400800" cy="347472"/>
+          </a:xfrm>
+          <a:prstGeom prst="rect">
+            <a:avLst/>
+          </a:prstGeom>
+          <a:noFill/>
+        </p:spPr>
+        <p:txBody>
+          <a:bodyPr wrap="square">
+            <a:spAutoFit/>
+          </a:bodyPr>
+          <a:lstStyle/>
+          <a:p>
+            <a:pPr algn="l"/>
+            <a:r>
+              <a:rPr sz="1050" b="0" i="0">
                 <a:solidFill>
                   <a:srgbClr val="333333"/>
                 </a:solidFill>
               </a:rPr>
-              <a:t>Prompt construction, JSON parse, rule validation</a:t>
+              <a:t>Statistical rules, code-column skipping, ceiling rounding</a:t>
             </a:r>
           </a:p>
         </p:txBody>
@@ -24849,7 +24731,7 @@
         </p:nvSpPr>
         <p:spPr>
           <a:xfrm>
-            <a:off x="457200" y="2999232"/>
+            <a:off x="457200" y="2953511"/>
             <a:ext cx="3840480" cy="347472"/>
           </a:xfrm>
           <a:prstGeom prst="rect">
@@ -24892,7 +24774,7 @@
         </p:nvSpPr>
         <p:spPr>
           <a:xfrm>
-            <a:off x="502920" y="3037332"/>
+            <a:off x="502920" y="2991611"/>
             <a:ext cx="3749040" cy="347472"/>
           </a:xfrm>
           <a:prstGeom prst="rect">
@@ -24908,12 +24790,12 @@
           <a:p>
             <a:pPr algn="l"/>
             <a:r>
-              <a:rPr sz="1300" b="0" i="0">
+              <a:rPr sz="1050" b="0" i="0">
                 <a:solidFill>
                   <a:srgbClr val="333333"/>
                 </a:solidFill>
               </a:rPr>
-              <a:t>tests/test_rule_metrics.py</a:t>
+              <a:t>tests/test_rule_writer.py</a:t>
             </a:r>
           </a:p>
         </p:txBody>
@@ -24926,8 +24808,8 @@
         </p:nvSpPr>
         <p:spPr>
           <a:xfrm>
-            <a:off x="4297680" y="2999232"/>
-            <a:ext cx="1005840" cy="347472"/>
+            <a:off x="4297680" y="2953511"/>
+            <a:ext cx="914400" cy="347472"/>
           </a:xfrm>
           <a:prstGeom prst="rect">
             <a:avLst/>
@@ -24969,28 +24851,28 @@
         </p:nvSpPr>
         <p:spPr>
           <a:xfrm>
-            <a:off x="4343400" y="3037332"/>
-            <a:ext cx="914400" cy="347472"/>
-          </a:xfrm>
-          <a:prstGeom prst="rect">
-            <a:avLst/>
-          </a:prstGeom>
-          <a:noFill/>
-        </p:spPr>
-        <p:txBody>
-          <a:bodyPr wrap="square">
-            <a:spAutoFit/>
-          </a:bodyPr>
-          <a:lstStyle/>
-          <a:p>
-            <a:pPr algn="l"/>
-            <a:r>
-              <a:rPr sz="1300" b="0" i="0">
+            <a:off x="4343400" y="2991611"/>
+            <a:ext cx="822960" cy="347472"/>
+          </a:xfrm>
+          <a:prstGeom prst="rect">
+            <a:avLst/>
+          </a:prstGeom>
+          <a:noFill/>
+        </p:spPr>
+        <p:txBody>
+          <a:bodyPr wrap="square">
+            <a:spAutoFit/>
+          </a:bodyPr>
+          <a:lstStyle/>
+          <a:p>
+            <a:pPr algn="l"/>
+            <a:r>
+              <a:rPr sz="1050" b="0" i="0">
                 <a:solidFill>
                   <a:srgbClr val="333333"/>
                 </a:solidFill>
               </a:rPr>
-              <a:t>9</a:t>
+              <a:t>11</a:t>
             </a:r>
           </a:p>
         </p:txBody>
@@ -25003,8 +24885,8 @@
         </p:nvSpPr>
         <p:spPr>
           <a:xfrm>
-            <a:off x="5303520" y="2999232"/>
-            <a:ext cx="6400800" cy="347472"/>
+            <a:off x="5212080" y="2953511"/>
+            <a:ext cx="6492240" cy="347472"/>
           </a:xfrm>
           <a:prstGeom prst="rect">
             <a:avLst/>
@@ -25046,28 +24928,28 @@
         </p:nvSpPr>
         <p:spPr>
           <a:xfrm>
-            <a:off x="5349240" y="3037332"/>
-            <a:ext cx="6309360" cy="347472"/>
-          </a:xfrm>
-          <a:prstGeom prst="rect">
-            <a:avLst/>
-          </a:prstGeom>
-          <a:noFill/>
-        </p:spPr>
-        <p:txBody>
-          <a:bodyPr wrap="square">
-            <a:spAutoFit/>
-          </a:bodyPr>
-          <a:lstStyle/>
-          <a:p>
-            <a:pPr algn="l"/>
-            <a:r>
-              <a:rPr sz="1300" b="0" i="0">
+            <a:off x="5257800" y="2991611"/>
+            <a:ext cx="6400800" cy="347472"/>
+          </a:xfrm>
+          <a:prstGeom prst="rect">
+            <a:avLst/>
+          </a:prstGeom>
+          <a:noFill/>
+        </p:spPr>
+        <p:txBody>
+          <a:bodyPr wrap="square">
+            <a:spAutoFit/>
+          </a:bodyPr>
+          <a:lstStyle/>
+          <a:p>
+            <a:pPr algn="l"/>
+            <a:r>
+              <a:rPr sz="1050" b="0" i="0">
                 <a:solidFill>
                   <a:srgbClr val="333333"/>
                 </a:solidFill>
               </a:rPr>
-              <a:t>Metrics dict building, violation % calc, write path</a:t>
+              <a:t>DQX-name translation on promotion, duplicate filtering</a:t>
             </a:r>
           </a:p>
         </p:txBody>
@@ -25080,7 +24962,7 @@
         </p:nvSpPr>
         <p:spPr>
           <a:xfrm>
-            <a:off x="457200" y="3346704"/>
+            <a:off x="457200" y="3300983"/>
             <a:ext cx="3840480" cy="347472"/>
           </a:xfrm>
           <a:prstGeom prst="rect">
@@ -25123,7 +25005,7 @@
         </p:nvSpPr>
         <p:spPr>
           <a:xfrm>
-            <a:off x="502920" y="3384804"/>
+            <a:off x="502920" y="3339083"/>
             <a:ext cx="3749040" cy="347472"/>
           </a:xfrm>
           <a:prstGeom prst="rect">
@@ -25139,12 +25021,12 @@
           <a:p>
             <a:pPr algn="l"/>
             <a:r>
-              <a:rPr sz="1300" b="0" i="0">
+              <a:rPr sz="1050" b="0" i="0">
                 <a:solidFill>
                   <a:srgbClr val="333333"/>
                 </a:solidFill>
               </a:rPr>
-              <a:t>tests/test_rule_writer.py</a:t>
+              <a:t>tests/test_rule_seed.py</a:t>
             </a:r>
           </a:p>
         </p:txBody>
@@ -25157,8 +25039,8 @@
         </p:nvSpPr>
         <p:spPr>
           <a:xfrm>
-            <a:off x="4297680" y="3346704"/>
-            <a:ext cx="1005840" cy="347472"/>
+            <a:off x="4297680" y="3300983"/>
+            <a:ext cx="914400" cy="347472"/>
           </a:xfrm>
           <a:prstGeom prst="rect">
             <a:avLst/>
@@ -25200,28 +25082,28 @@
         </p:nvSpPr>
         <p:spPr>
           <a:xfrm>
-            <a:off x="4343400" y="3384804"/>
-            <a:ext cx="914400" cy="347472"/>
-          </a:xfrm>
-          <a:prstGeom prst="rect">
-            <a:avLst/>
-          </a:prstGeom>
-          <a:noFill/>
-        </p:spPr>
-        <p:txBody>
-          <a:bodyPr wrap="square">
-            <a:spAutoFit/>
-          </a:bodyPr>
-          <a:lstStyle/>
-          <a:p>
-            <a:pPr algn="l"/>
-            <a:r>
-              <a:rPr sz="1300" b="0" i="0">
+            <a:off x="4343400" y="3339083"/>
+            <a:ext cx="822960" cy="347472"/>
+          </a:xfrm>
+          <a:prstGeom prst="rect">
+            <a:avLst/>
+          </a:prstGeom>
+          <a:noFill/>
+        </p:spPr>
+        <p:txBody>
+          <a:bodyPr wrap="square">
+            <a:spAutoFit/>
+          </a:bodyPr>
+          <a:lstStyle/>
+          <a:p>
+            <a:pPr algn="l"/>
+            <a:r>
+              <a:rPr sz="1050" b="0" i="0">
                 <a:solidFill>
                   <a:srgbClr val="333333"/>
                 </a:solidFill>
               </a:rPr>
-              <a:t>9</a:t>
+              <a:t>7</a:t>
             </a:r>
           </a:p>
         </p:txBody>
@@ -25234,8 +25116,8 @@
         </p:nvSpPr>
         <p:spPr>
           <a:xfrm>
-            <a:off x="5303520" y="3346704"/>
-            <a:ext cx="6400800" cy="347472"/>
+            <a:off x="5212080" y="3300983"/>
+            <a:ext cx="6492240" cy="347472"/>
           </a:xfrm>
           <a:prstGeom prst="rect">
             <a:avLst/>
@@ -25277,28 +25159,28 @@
         </p:nvSpPr>
         <p:spPr>
           <a:xfrm>
-            <a:off x="5349240" y="3384804"/>
-            <a:ext cx="6309360" cy="347472"/>
-          </a:xfrm>
-          <a:prstGeom prst="rect">
-            <a:avLst/>
-          </a:prstGeom>
-          <a:noFill/>
-        </p:spPr>
-        <p:txBody>
-          <a:bodyPr wrap="square">
-            <a:spAutoFit/>
-          </a:bodyPr>
-          <a:lstStyle/>
-          <a:p>
-            <a:pPr algn="l"/>
-            <a:r>
-              <a:rPr sz="1300" b="0" i="0">
+            <a:off x="5257800" y="3339083"/>
+            <a:ext cx="6400800" cy="347472"/>
+          </a:xfrm>
+          <a:prstGeom prst="rect">
+            <a:avLst/>
+          </a:prstGeom>
+          <a:noFill/>
+        </p:spPr>
+        <p:txBody>
+          <a:bodyPr wrap="square">
+            <a:spAutoFit/>
+          </a:bodyPr>
+          <a:lstStyle/>
+          <a:p>
+            <a:pPr algn="l"/>
+            <a:r>
+              <a:rPr sz="1050" b="0" i="0">
                 <a:solidFill>
                   <a:srgbClr val="333333"/>
                 </a:solidFill>
               </a:rPr>
-              <a:t>Staging insert, approve/reject lifecycle, registry promotion</a:t>
+              <a:t>YAML → DQX-native check conversion for every rule type</a:t>
             </a:r>
           </a:p>
         </p:txBody>
@@ -25311,14 +25193,14 @@
         </p:nvSpPr>
         <p:spPr>
           <a:xfrm>
-            <a:off x="457200" y="3566160"/>
-            <a:ext cx="4572000" cy="1097280"/>
-          </a:xfrm>
-          <a:prstGeom prst="rect">
-            <a:avLst/>
-          </a:prstGeom>
-          <a:solidFill>
-            <a:srgbClr val="1E1E2E"/>
+            <a:off x="457200" y="3648455"/>
+            <a:ext cx="3840480" cy="347472"/>
+          </a:xfrm>
+          <a:prstGeom prst="rect">
+            <a:avLst/>
+          </a:prstGeom>
+          <a:solidFill>
+            <a:srgbClr val="F7F9FC"/>
           </a:solidFill>
           <a:ln>
             <a:noFill/>
@@ -25348,20 +25230,54 @@
       </p:sp>
       <p:sp>
         <p:nvSpPr>
-          <p:cNvPr id="36" name="Rectangle 35"/>
-          <p:cNvSpPr/>
-          <p:nvPr/>
-        </p:nvSpPr>
-        <p:spPr>
-          <a:xfrm>
-            <a:off x="457200" y="3566160"/>
-            <a:ext cx="50800" cy="1097280"/>
-          </a:xfrm>
-          <a:prstGeom prst="rect">
-            <a:avLst/>
-          </a:prstGeom>
-          <a:solidFill>
-            <a:srgbClr val="E94560"/>
+          <p:cNvPr id="36" name="TextBox 35"/>
+          <p:cNvSpPr txBox="1"/>
+          <p:nvPr/>
+        </p:nvSpPr>
+        <p:spPr>
+          <a:xfrm>
+            <a:off x="502920" y="3686555"/>
+            <a:ext cx="3749040" cy="347472"/>
+          </a:xfrm>
+          <a:prstGeom prst="rect">
+            <a:avLst/>
+          </a:prstGeom>
+          <a:noFill/>
+        </p:spPr>
+        <p:txBody>
+          <a:bodyPr wrap="square">
+            <a:spAutoFit/>
+          </a:bodyPr>
+          <a:lstStyle/>
+          <a:p>
+            <a:pPr algn="l"/>
+            <a:r>
+              <a:rPr sz="1050" b="0" i="0">
+                <a:solidFill>
+                  <a:srgbClr val="333333"/>
+                </a:solidFill>
+              </a:rPr>
+              <a:t>tests/test_quarantine_analyzer.py</a:t>
+            </a:r>
+          </a:p>
+        </p:txBody>
+      </p:sp>
+      <p:sp>
+        <p:nvSpPr>
+          <p:cNvPr id="37" name="Rectangle 36"/>
+          <p:cNvSpPr/>
+          <p:nvPr/>
+        </p:nvSpPr>
+        <p:spPr>
+          <a:xfrm>
+            <a:off x="4297680" y="3648455"/>
+            <a:ext cx="914400" cy="347472"/>
+          </a:xfrm>
+          <a:prstGeom prst="rect">
+            <a:avLst/>
+          </a:prstGeom>
+          <a:solidFill>
+            <a:srgbClr val="F7F9FC"/>
           </a:solidFill>
           <a:ln>
             <a:noFill/>
@@ -25391,14 +25307,1135 @@
       </p:sp>
       <p:sp>
         <p:nvSpPr>
-          <p:cNvPr id="37" name="TextBox 36"/>
-          <p:cNvSpPr txBox="1"/>
-          <p:nvPr/>
-        </p:nvSpPr>
-        <p:spPr>
-          <a:xfrm>
-            <a:off x="566928" y="3657600"/>
-            <a:ext cx="4407408" cy="914400"/>
+          <p:cNvPr id="38" name="TextBox 37"/>
+          <p:cNvSpPr txBox="1"/>
+          <p:nvPr/>
+        </p:nvSpPr>
+        <p:spPr>
+          <a:xfrm>
+            <a:off x="4343400" y="3686555"/>
+            <a:ext cx="822960" cy="347472"/>
+          </a:xfrm>
+          <a:prstGeom prst="rect">
+            <a:avLst/>
+          </a:prstGeom>
+          <a:noFill/>
+        </p:spPr>
+        <p:txBody>
+          <a:bodyPr wrap="square">
+            <a:spAutoFit/>
+          </a:bodyPr>
+          <a:lstStyle/>
+          <a:p>
+            <a:pPr algn="l"/>
+            <a:r>
+              <a:rPr sz="1050" b="0" i="0">
+                <a:solidFill>
+                  <a:srgbClr val="333333"/>
+                </a:solidFill>
+              </a:rPr>
+              <a:t>14</a:t>
+            </a:r>
+          </a:p>
+        </p:txBody>
+      </p:sp>
+      <p:sp>
+        <p:nvSpPr>
+          <p:cNvPr id="39" name="Rectangle 38"/>
+          <p:cNvSpPr/>
+          <p:nvPr/>
+        </p:nvSpPr>
+        <p:spPr>
+          <a:xfrm>
+            <a:off x="5212080" y="3648455"/>
+            <a:ext cx="6492240" cy="347472"/>
+          </a:xfrm>
+          <a:prstGeom prst="rect">
+            <a:avLst/>
+          </a:prstGeom>
+          <a:solidFill>
+            <a:srgbClr val="F7F9FC"/>
+          </a:solidFill>
+          <a:ln>
+            <a:noFill/>
+          </a:ln>
+        </p:spPr>
+        <p:style>
+          <a:lnRef idx="1">
+            <a:schemeClr val="accent1"/>
+          </a:lnRef>
+          <a:fillRef idx="3">
+            <a:schemeClr val="accent1"/>
+          </a:fillRef>
+          <a:effectRef idx="2">
+            <a:schemeClr val="accent1"/>
+          </a:effectRef>
+          <a:fontRef idx="minor">
+            <a:schemeClr val="lt1"/>
+          </a:fontRef>
+        </p:style>
+        <p:txBody>
+          <a:bodyPr rtlCol="0" anchor="ctr"/>
+          <a:lstStyle/>
+          <a:p>
+            <a:pPr algn="ctr"/>
+          </a:p>
+        </p:txBody>
+      </p:sp>
+      <p:sp>
+        <p:nvSpPr>
+          <p:cNvPr id="40" name="TextBox 39"/>
+          <p:cNvSpPr txBox="1"/>
+          <p:nvPr/>
+        </p:nvSpPr>
+        <p:spPr>
+          <a:xfrm>
+            <a:off x="5257800" y="3686555"/>
+            <a:ext cx="6400800" cy="347472"/>
+          </a:xfrm>
+          <a:prstGeom prst="rect">
+            <a:avLst/>
+          </a:prstGeom>
+          <a:noFill/>
+        </p:spPr>
+        <p:txBody>
+          <a:bodyPr wrap="square">
+            <a:spAutoFit/>
+          </a:bodyPr>
+          <a:lstStyle/>
+          <a:p>
+            <a:pPr algn="l"/>
+            <a:r>
+              <a:rPr sz="1050" b="0" i="0">
+                <a:solidFill>
+                  <a:srgbClr val="333333"/>
+                </a:solidFill>
+              </a:rPr>
+              <a:t>Prompt construction, JSON parsing, rule validation</a:t>
+            </a:r>
+          </a:p>
+        </p:txBody>
+      </p:sp>
+      <p:sp>
+        <p:nvSpPr>
+          <p:cNvPr id="41" name="Rectangle 40"/>
+          <p:cNvSpPr/>
+          <p:nvPr/>
+        </p:nvSpPr>
+        <p:spPr>
+          <a:xfrm>
+            <a:off x="457200" y="3995927"/>
+            <a:ext cx="3840480" cy="347472"/>
+          </a:xfrm>
+          <a:prstGeom prst="rect">
+            <a:avLst/>
+          </a:prstGeom>
+          <a:solidFill>
+            <a:srgbClr val="FFFFFF"/>
+          </a:solidFill>
+          <a:ln>
+            <a:noFill/>
+          </a:ln>
+        </p:spPr>
+        <p:style>
+          <a:lnRef idx="1">
+            <a:schemeClr val="accent1"/>
+          </a:lnRef>
+          <a:fillRef idx="3">
+            <a:schemeClr val="accent1"/>
+          </a:fillRef>
+          <a:effectRef idx="2">
+            <a:schemeClr val="accent1"/>
+          </a:effectRef>
+          <a:fontRef idx="minor">
+            <a:schemeClr val="lt1"/>
+          </a:fontRef>
+        </p:style>
+        <p:txBody>
+          <a:bodyPr rtlCol="0" anchor="ctr"/>
+          <a:lstStyle/>
+          <a:p>
+            <a:pPr algn="ctr"/>
+          </a:p>
+        </p:txBody>
+      </p:sp>
+      <p:sp>
+        <p:nvSpPr>
+          <p:cNvPr id="42" name="TextBox 41"/>
+          <p:cNvSpPr txBox="1"/>
+          <p:nvPr/>
+        </p:nvSpPr>
+        <p:spPr>
+          <a:xfrm>
+            <a:off x="502920" y="4034027"/>
+            <a:ext cx="3749040" cy="347472"/>
+          </a:xfrm>
+          <a:prstGeom prst="rect">
+            <a:avLst/>
+          </a:prstGeom>
+          <a:noFill/>
+        </p:spPr>
+        <p:txBody>
+          <a:bodyPr wrap="square">
+            <a:spAutoFit/>
+          </a:bodyPr>
+          <a:lstStyle/>
+          <a:p>
+            <a:pPr algn="l"/>
+            <a:r>
+              <a:rPr sz="1050" b="0" i="0">
+                <a:solidFill>
+                  <a:srgbClr val="333333"/>
+                </a:solidFill>
+              </a:rPr>
+              <a:t>tests/test_rule_metrics.py</a:t>
+            </a:r>
+          </a:p>
+        </p:txBody>
+      </p:sp>
+      <p:sp>
+        <p:nvSpPr>
+          <p:cNvPr id="43" name="Rectangle 42"/>
+          <p:cNvSpPr/>
+          <p:nvPr/>
+        </p:nvSpPr>
+        <p:spPr>
+          <a:xfrm>
+            <a:off x="4297680" y="3995927"/>
+            <a:ext cx="914400" cy="347472"/>
+          </a:xfrm>
+          <a:prstGeom prst="rect">
+            <a:avLst/>
+          </a:prstGeom>
+          <a:solidFill>
+            <a:srgbClr val="FFFFFF"/>
+          </a:solidFill>
+          <a:ln>
+            <a:noFill/>
+          </a:ln>
+        </p:spPr>
+        <p:style>
+          <a:lnRef idx="1">
+            <a:schemeClr val="accent1"/>
+          </a:lnRef>
+          <a:fillRef idx="3">
+            <a:schemeClr val="accent1"/>
+          </a:fillRef>
+          <a:effectRef idx="2">
+            <a:schemeClr val="accent1"/>
+          </a:effectRef>
+          <a:fontRef idx="minor">
+            <a:schemeClr val="lt1"/>
+          </a:fontRef>
+        </p:style>
+        <p:txBody>
+          <a:bodyPr rtlCol="0" anchor="ctr"/>
+          <a:lstStyle/>
+          <a:p>
+            <a:pPr algn="ctr"/>
+          </a:p>
+        </p:txBody>
+      </p:sp>
+      <p:sp>
+        <p:nvSpPr>
+          <p:cNvPr id="44" name="TextBox 43"/>
+          <p:cNvSpPr txBox="1"/>
+          <p:nvPr/>
+        </p:nvSpPr>
+        <p:spPr>
+          <a:xfrm>
+            <a:off x="4343400" y="4034027"/>
+            <a:ext cx="822960" cy="347472"/>
+          </a:xfrm>
+          <a:prstGeom prst="rect">
+            <a:avLst/>
+          </a:prstGeom>
+          <a:noFill/>
+        </p:spPr>
+        <p:txBody>
+          <a:bodyPr wrap="square">
+            <a:spAutoFit/>
+          </a:bodyPr>
+          <a:lstStyle/>
+          <a:p>
+            <a:pPr algn="l"/>
+            <a:r>
+              <a:rPr sz="1050" b="0" i="0">
+                <a:solidFill>
+                  <a:srgbClr val="333333"/>
+                </a:solidFill>
+              </a:rPr>
+              <a:t>9</a:t>
+            </a:r>
+          </a:p>
+        </p:txBody>
+      </p:sp>
+      <p:sp>
+        <p:nvSpPr>
+          <p:cNvPr id="45" name="Rectangle 44"/>
+          <p:cNvSpPr/>
+          <p:nvPr/>
+        </p:nvSpPr>
+        <p:spPr>
+          <a:xfrm>
+            <a:off x="5212080" y="3995927"/>
+            <a:ext cx="6492240" cy="347472"/>
+          </a:xfrm>
+          <a:prstGeom prst="rect">
+            <a:avLst/>
+          </a:prstGeom>
+          <a:solidFill>
+            <a:srgbClr val="FFFFFF"/>
+          </a:solidFill>
+          <a:ln>
+            <a:noFill/>
+          </a:ln>
+        </p:spPr>
+        <p:style>
+          <a:lnRef idx="1">
+            <a:schemeClr val="accent1"/>
+          </a:lnRef>
+          <a:fillRef idx="3">
+            <a:schemeClr val="accent1"/>
+          </a:fillRef>
+          <a:effectRef idx="2">
+            <a:schemeClr val="accent1"/>
+          </a:effectRef>
+          <a:fontRef idx="minor">
+            <a:schemeClr val="lt1"/>
+          </a:fontRef>
+        </p:style>
+        <p:txBody>
+          <a:bodyPr rtlCol="0" anchor="ctr"/>
+          <a:lstStyle/>
+          <a:p>
+            <a:pPr algn="ctr"/>
+          </a:p>
+        </p:txBody>
+      </p:sp>
+      <p:sp>
+        <p:nvSpPr>
+          <p:cNvPr id="46" name="TextBox 45"/>
+          <p:cNvSpPr txBox="1"/>
+          <p:nvPr/>
+        </p:nvSpPr>
+        <p:spPr>
+          <a:xfrm>
+            <a:off x="5257800" y="4034027"/>
+            <a:ext cx="6400800" cy="347472"/>
+          </a:xfrm>
+          <a:prstGeom prst="rect">
+            <a:avLst/>
+          </a:prstGeom>
+          <a:noFill/>
+        </p:spPr>
+        <p:txBody>
+          <a:bodyPr wrap="square">
+            <a:spAutoFit/>
+          </a:bodyPr>
+          <a:lstStyle/>
+          <a:p>
+            <a:pPr algn="l"/>
+            <a:r>
+              <a:rPr sz="1050" b="0" i="0">
+                <a:solidFill>
+                  <a:srgbClr val="333333"/>
+                </a:solidFill>
+              </a:rPr>
+              <a:t>Metrics building, violation % calculation, write path</a:t>
+            </a:r>
+          </a:p>
+        </p:txBody>
+      </p:sp>
+      <p:sp>
+        <p:nvSpPr>
+          <p:cNvPr id="47" name="Rectangle 46"/>
+          <p:cNvSpPr/>
+          <p:nvPr/>
+        </p:nvSpPr>
+        <p:spPr>
+          <a:xfrm>
+            <a:off x="457200" y="4343399"/>
+            <a:ext cx="3840480" cy="347472"/>
+          </a:xfrm>
+          <a:prstGeom prst="rect">
+            <a:avLst/>
+          </a:prstGeom>
+          <a:solidFill>
+            <a:srgbClr val="F7F9FC"/>
+          </a:solidFill>
+          <a:ln>
+            <a:noFill/>
+          </a:ln>
+        </p:spPr>
+        <p:style>
+          <a:lnRef idx="1">
+            <a:schemeClr val="accent1"/>
+          </a:lnRef>
+          <a:fillRef idx="3">
+            <a:schemeClr val="accent1"/>
+          </a:fillRef>
+          <a:effectRef idx="2">
+            <a:schemeClr val="accent1"/>
+          </a:effectRef>
+          <a:fontRef idx="minor">
+            <a:schemeClr val="lt1"/>
+          </a:fontRef>
+        </p:style>
+        <p:txBody>
+          <a:bodyPr rtlCol="0" anchor="ctr"/>
+          <a:lstStyle/>
+          <a:p>
+            <a:pPr algn="ctr"/>
+          </a:p>
+        </p:txBody>
+      </p:sp>
+      <p:sp>
+        <p:nvSpPr>
+          <p:cNvPr id="48" name="TextBox 47"/>
+          <p:cNvSpPr txBox="1"/>
+          <p:nvPr/>
+        </p:nvSpPr>
+        <p:spPr>
+          <a:xfrm>
+            <a:off x="502920" y="4381499"/>
+            <a:ext cx="3749040" cy="347472"/>
+          </a:xfrm>
+          <a:prstGeom prst="rect">
+            <a:avLst/>
+          </a:prstGeom>
+          <a:noFill/>
+        </p:spPr>
+        <p:txBody>
+          <a:bodyPr wrap="square">
+            <a:spAutoFit/>
+          </a:bodyPr>
+          <a:lstStyle/>
+          <a:p>
+            <a:pPr algn="l"/>
+            <a:r>
+              <a:rPr sz="1050" b="0" i="0">
+                <a:solidFill>
+                  <a:srgbClr val="333333"/>
+                </a:solidFill>
+              </a:rPr>
+              <a:t>tests/test_alerting.py</a:t>
+            </a:r>
+          </a:p>
+        </p:txBody>
+      </p:sp>
+      <p:sp>
+        <p:nvSpPr>
+          <p:cNvPr id="49" name="Rectangle 48"/>
+          <p:cNvSpPr/>
+          <p:nvPr/>
+        </p:nvSpPr>
+        <p:spPr>
+          <a:xfrm>
+            <a:off x="4297680" y="4343399"/>
+            <a:ext cx="914400" cy="347472"/>
+          </a:xfrm>
+          <a:prstGeom prst="rect">
+            <a:avLst/>
+          </a:prstGeom>
+          <a:solidFill>
+            <a:srgbClr val="F7F9FC"/>
+          </a:solidFill>
+          <a:ln>
+            <a:noFill/>
+          </a:ln>
+        </p:spPr>
+        <p:style>
+          <a:lnRef idx="1">
+            <a:schemeClr val="accent1"/>
+          </a:lnRef>
+          <a:fillRef idx="3">
+            <a:schemeClr val="accent1"/>
+          </a:fillRef>
+          <a:effectRef idx="2">
+            <a:schemeClr val="accent1"/>
+          </a:effectRef>
+          <a:fontRef idx="minor">
+            <a:schemeClr val="lt1"/>
+          </a:fontRef>
+        </p:style>
+        <p:txBody>
+          <a:bodyPr rtlCol="0" anchor="ctr"/>
+          <a:lstStyle/>
+          <a:p>
+            <a:pPr algn="ctr"/>
+          </a:p>
+        </p:txBody>
+      </p:sp>
+      <p:sp>
+        <p:nvSpPr>
+          <p:cNvPr id="50" name="TextBox 49"/>
+          <p:cNvSpPr txBox="1"/>
+          <p:nvPr/>
+        </p:nvSpPr>
+        <p:spPr>
+          <a:xfrm>
+            <a:off x="4343400" y="4381499"/>
+            <a:ext cx="822960" cy="347472"/>
+          </a:xfrm>
+          <a:prstGeom prst="rect">
+            <a:avLst/>
+          </a:prstGeom>
+          <a:noFill/>
+        </p:spPr>
+        <p:txBody>
+          <a:bodyPr wrap="square">
+            <a:spAutoFit/>
+          </a:bodyPr>
+          <a:lstStyle/>
+          <a:p>
+            <a:pPr algn="l"/>
+            <a:r>
+              <a:rPr sz="1050" b="0" i="0">
+                <a:solidFill>
+                  <a:srgbClr val="333333"/>
+                </a:solidFill>
+              </a:rPr>
+              <a:t>11</a:t>
+            </a:r>
+          </a:p>
+        </p:txBody>
+      </p:sp>
+      <p:sp>
+        <p:nvSpPr>
+          <p:cNvPr id="51" name="Rectangle 50"/>
+          <p:cNvSpPr/>
+          <p:nvPr/>
+        </p:nvSpPr>
+        <p:spPr>
+          <a:xfrm>
+            <a:off x="5212080" y="4343399"/>
+            <a:ext cx="6492240" cy="347472"/>
+          </a:xfrm>
+          <a:prstGeom prst="rect">
+            <a:avLst/>
+          </a:prstGeom>
+          <a:solidFill>
+            <a:srgbClr val="F7F9FC"/>
+          </a:solidFill>
+          <a:ln>
+            <a:noFill/>
+          </a:ln>
+        </p:spPr>
+        <p:style>
+          <a:lnRef idx="1">
+            <a:schemeClr val="accent1"/>
+          </a:lnRef>
+          <a:fillRef idx="3">
+            <a:schemeClr val="accent1"/>
+          </a:fillRef>
+          <a:effectRef idx="2">
+            <a:schemeClr val="accent1"/>
+          </a:effectRef>
+          <a:fontRef idx="minor">
+            <a:schemeClr val="lt1"/>
+          </a:fontRef>
+        </p:style>
+        <p:txBody>
+          <a:bodyPr rtlCol="0" anchor="ctr"/>
+          <a:lstStyle/>
+          <a:p>
+            <a:pPr algn="ctr"/>
+          </a:p>
+        </p:txBody>
+      </p:sp>
+      <p:sp>
+        <p:nvSpPr>
+          <p:cNvPr id="52" name="TextBox 51"/>
+          <p:cNvSpPr txBox="1"/>
+          <p:nvPr/>
+        </p:nvSpPr>
+        <p:spPr>
+          <a:xfrm>
+            <a:off x="5257800" y="4381499"/>
+            <a:ext cx="6400800" cy="347472"/>
+          </a:xfrm>
+          <a:prstGeom prst="rect">
+            <a:avLst/>
+          </a:prstGeom>
+          <a:noFill/>
+        </p:spPr>
+        <p:txBody>
+          <a:bodyPr wrap="square">
+            <a:spAutoFit/>
+          </a:bodyPr>
+          <a:lstStyle/>
+          <a:p>
+            <a:pPr algn="l"/>
+            <a:r>
+              <a:rPr sz="1050" b="0" i="0">
+                <a:solidFill>
+                  <a:srgbClr val="333333"/>
+                </a:solidFill>
+              </a:rPr>
+              <a:t>Spike detection, Slack payload and delivery, orchestration</a:t>
+            </a:r>
+          </a:p>
+        </p:txBody>
+      </p:sp>
+      <p:sp>
+        <p:nvSpPr>
+          <p:cNvPr id="53" name="Rectangle 52"/>
+          <p:cNvSpPr/>
+          <p:nvPr/>
+        </p:nvSpPr>
+        <p:spPr>
+          <a:xfrm>
+            <a:off x="457200" y="4690871"/>
+            <a:ext cx="3840480" cy="347472"/>
+          </a:xfrm>
+          <a:prstGeom prst="rect">
+            <a:avLst/>
+          </a:prstGeom>
+          <a:solidFill>
+            <a:srgbClr val="FFFFFF"/>
+          </a:solidFill>
+          <a:ln>
+            <a:noFill/>
+          </a:ln>
+        </p:spPr>
+        <p:style>
+          <a:lnRef idx="1">
+            <a:schemeClr val="accent1"/>
+          </a:lnRef>
+          <a:fillRef idx="3">
+            <a:schemeClr val="accent1"/>
+          </a:fillRef>
+          <a:effectRef idx="2">
+            <a:schemeClr val="accent1"/>
+          </a:effectRef>
+          <a:fontRef idx="minor">
+            <a:schemeClr val="lt1"/>
+          </a:fontRef>
+        </p:style>
+        <p:txBody>
+          <a:bodyPr rtlCol="0" anchor="ctr"/>
+          <a:lstStyle/>
+          <a:p>
+            <a:pPr algn="ctr"/>
+          </a:p>
+        </p:txBody>
+      </p:sp>
+      <p:sp>
+        <p:nvSpPr>
+          <p:cNvPr id="54" name="TextBox 53"/>
+          <p:cNvSpPr txBox="1"/>
+          <p:nvPr/>
+        </p:nvSpPr>
+        <p:spPr>
+          <a:xfrm>
+            <a:off x="502920" y="4728971"/>
+            <a:ext cx="3749040" cy="347472"/>
+          </a:xfrm>
+          <a:prstGeom prst="rect">
+            <a:avLst/>
+          </a:prstGeom>
+          <a:noFill/>
+        </p:spPr>
+        <p:txBody>
+          <a:bodyPr wrap="square">
+            <a:spAutoFit/>
+          </a:bodyPr>
+          <a:lstStyle/>
+          <a:p>
+            <a:pPr algn="l"/>
+            <a:r>
+              <a:rPr sz="1050" b="0" i="0">
+                <a:solidFill>
+                  <a:srgbClr val="333333"/>
+                </a:solidFill>
+              </a:rPr>
+              <a:t>tests/test_config.py</a:t>
+            </a:r>
+          </a:p>
+        </p:txBody>
+      </p:sp>
+      <p:sp>
+        <p:nvSpPr>
+          <p:cNvPr id="55" name="Rectangle 54"/>
+          <p:cNvSpPr/>
+          <p:nvPr/>
+        </p:nvSpPr>
+        <p:spPr>
+          <a:xfrm>
+            <a:off x="4297680" y="4690871"/>
+            <a:ext cx="914400" cy="347472"/>
+          </a:xfrm>
+          <a:prstGeom prst="rect">
+            <a:avLst/>
+          </a:prstGeom>
+          <a:solidFill>
+            <a:srgbClr val="FFFFFF"/>
+          </a:solidFill>
+          <a:ln>
+            <a:noFill/>
+          </a:ln>
+        </p:spPr>
+        <p:style>
+          <a:lnRef idx="1">
+            <a:schemeClr val="accent1"/>
+          </a:lnRef>
+          <a:fillRef idx="3">
+            <a:schemeClr val="accent1"/>
+          </a:fillRef>
+          <a:effectRef idx="2">
+            <a:schemeClr val="accent1"/>
+          </a:effectRef>
+          <a:fontRef idx="minor">
+            <a:schemeClr val="lt1"/>
+          </a:fontRef>
+        </p:style>
+        <p:txBody>
+          <a:bodyPr rtlCol="0" anchor="ctr"/>
+          <a:lstStyle/>
+          <a:p>
+            <a:pPr algn="ctr"/>
+          </a:p>
+        </p:txBody>
+      </p:sp>
+      <p:sp>
+        <p:nvSpPr>
+          <p:cNvPr id="56" name="TextBox 55"/>
+          <p:cNvSpPr txBox="1"/>
+          <p:nvPr/>
+        </p:nvSpPr>
+        <p:spPr>
+          <a:xfrm>
+            <a:off x="4343400" y="4728971"/>
+            <a:ext cx="822960" cy="347472"/>
+          </a:xfrm>
+          <a:prstGeom prst="rect">
+            <a:avLst/>
+          </a:prstGeom>
+          <a:noFill/>
+        </p:spPr>
+        <p:txBody>
+          <a:bodyPr wrap="square">
+            <a:spAutoFit/>
+          </a:bodyPr>
+          <a:lstStyle/>
+          <a:p>
+            <a:pPr algn="l"/>
+            <a:r>
+              <a:rPr sz="1050" b="0" i="0">
+                <a:solidFill>
+                  <a:srgbClr val="333333"/>
+                </a:solidFill>
+              </a:rPr>
+              <a:t>9</a:t>
+            </a:r>
+          </a:p>
+        </p:txBody>
+      </p:sp>
+      <p:sp>
+        <p:nvSpPr>
+          <p:cNvPr id="57" name="Rectangle 56"/>
+          <p:cNvSpPr/>
+          <p:nvPr/>
+        </p:nvSpPr>
+        <p:spPr>
+          <a:xfrm>
+            <a:off x="5212080" y="4690871"/>
+            <a:ext cx="6492240" cy="347472"/>
+          </a:xfrm>
+          <a:prstGeom prst="rect">
+            <a:avLst/>
+          </a:prstGeom>
+          <a:solidFill>
+            <a:srgbClr val="FFFFFF"/>
+          </a:solidFill>
+          <a:ln>
+            <a:noFill/>
+          </a:ln>
+        </p:spPr>
+        <p:style>
+          <a:lnRef idx="1">
+            <a:schemeClr val="accent1"/>
+          </a:lnRef>
+          <a:fillRef idx="3">
+            <a:schemeClr val="accent1"/>
+          </a:fillRef>
+          <a:effectRef idx="2">
+            <a:schemeClr val="accent1"/>
+          </a:effectRef>
+          <a:fontRef idx="minor">
+            <a:schemeClr val="lt1"/>
+          </a:fontRef>
+        </p:style>
+        <p:txBody>
+          <a:bodyPr rtlCol="0" anchor="ctr"/>
+          <a:lstStyle/>
+          <a:p>
+            <a:pPr algn="ctr"/>
+          </a:p>
+        </p:txBody>
+      </p:sp>
+      <p:sp>
+        <p:nvSpPr>
+          <p:cNvPr id="58" name="TextBox 57"/>
+          <p:cNvSpPr txBox="1"/>
+          <p:nvPr/>
+        </p:nvSpPr>
+        <p:spPr>
+          <a:xfrm>
+            <a:off x="5257800" y="4728971"/>
+            <a:ext cx="6400800" cy="347472"/>
+          </a:xfrm>
+          <a:prstGeom prst="rect">
+            <a:avLst/>
+          </a:prstGeom>
+          <a:noFill/>
+        </p:spPr>
+        <p:txBody>
+          <a:bodyPr wrap="square">
+            <a:spAutoFit/>
+          </a:bodyPr>
+          <a:lstStyle/>
+          <a:p>
+            <a:pPr algn="l"/>
+            <a:r>
+              <a:rPr sz="1050" b="0" i="0">
+                <a:solidFill>
+                  <a:srgbClr val="333333"/>
+                </a:solidFill>
+              </a:rPr>
+              <a:t>Settings loading and required-field validation</a:t>
+            </a:r>
+          </a:p>
+        </p:txBody>
+      </p:sp>
+      <p:sp>
+        <p:nvSpPr>
+          <p:cNvPr id="59" name="Rectangle 58"/>
+          <p:cNvSpPr/>
+          <p:nvPr/>
+        </p:nvSpPr>
+        <p:spPr>
+          <a:xfrm>
+            <a:off x="457200" y="5038343"/>
+            <a:ext cx="3840480" cy="347472"/>
+          </a:xfrm>
+          <a:prstGeom prst="rect">
+            <a:avLst/>
+          </a:prstGeom>
+          <a:solidFill>
+            <a:srgbClr val="F7F9FC"/>
+          </a:solidFill>
+          <a:ln>
+            <a:noFill/>
+          </a:ln>
+        </p:spPr>
+        <p:style>
+          <a:lnRef idx="1">
+            <a:schemeClr val="accent1"/>
+          </a:lnRef>
+          <a:fillRef idx="3">
+            <a:schemeClr val="accent1"/>
+          </a:fillRef>
+          <a:effectRef idx="2">
+            <a:schemeClr val="accent1"/>
+          </a:effectRef>
+          <a:fontRef idx="minor">
+            <a:schemeClr val="lt1"/>
+          </a:fontRef>
+        </p:style>
+        <p:txBody>
+          <a:bodyPr rtlCol="0" anchor="ctr"/>
+          <a:lstStyle/>
+          <a:p>
+            <a:pPr algn="ctr"/>
+          </a:p>
+        </p:txBody>
+      </p:sp>
+      <p:sp>
+        <p:nvSpPr>
+          <p:cNvPr id="60" name="TextBox 59"/>
+          <p:cNvSpPr txBox="1"/>
+          <p:nvPr/>
+        </p:nvSpPr>
+        <p:spPr>
+          <a:xfrm>
+            <a:off x="502920" y="5076443"/>
+            <a:ext cx="3749040" cy="347472"/>
+          </a:xfrm>
+          <a:prstGeom prst="rect">
+            <a:avLst/>
+          </a:prstGeom>
+          <a:noFill/>
+        </p:spPr>
+        <p:txBody>
+          <a:bodyPr wrap="square">
+            <a:spAutoFit/>
+          </a:bodyPr>
+          <a:lstStyle/>
+          <a:p>
+            <a:pPr algn="l"/>
+            <a:r>
+              <a:rPr sz="1050" b="0" i="0">
+                <a:solidFill>
+                  <a:srgbClr val="333333"/>
+                </a:solidFill>
+              </a:rPr>
+              <a:t>tests/test_event_generator.py</a:t>
+            </a:r>
+          </a:p>
+        </p:txBody>
+      </p:sp>
+      <p:sp>
+        <p:nvSpPr>
+          <p:cNvPr id="61" name="Rectangle 60"/>
+          <p:cNvSpPr/>
+          <p:nvPr/>
+        </p:nvSpPr>
+        <p:spPr>
+          <a:xfrm>
+            <a:off x="4297680" y="5038343"/>
+            <a:ext cx="914400" cy="347472"/>
+          </a:xfrm>
+          <a:prstGeom prst="rect">
+            <a:avLst/>
+          </a:prstGeom>
+          <a:solidFill>
+            <a:srgbClr val="F7F9FC"/>
+          </a:solidFill>
+          <a:ln>
+            <a:noFill/>
+          </a:ln>
+        </p:spPr>
+        <p:style>
+          <a:lnRef idx="1">
+            <a:schemeClr val="accent1"/>
+          </a:lnRef>
+          <a:fillRef idx="3">
+            <a:schemeClr val="accent1"/>
+          </a:fillRef>
+          <a:effectRef idx="2">
+            <a:schemeClr val="accent1"/>
+          </a:effectRef>
+          <a:fontRef idx="minor">
+            <a:schemeClr val="lt1"/>
+          </a:fontRef>
+        </p:style>
+        <p:txBody>
+          <a:bodyPr rtlCol="0" anchor="ctr"/>
+          <a:lstStyle/>
+          <a:p>
+            <a:pPr algn="ctr"/>
+          </a:p>
+        </p:txBody>
+      </p:sp>
+      <p:sp>
+        <p:nvSpPr>
+          <p:cNvPr id="62" name="TextBox 61"/>
+          <p:cNvSpPr txBox="1"/>
+          <p:nvPr/>
+        </p:nvSpPr>
+        <p:spPr>
+          <a:xfrm>
+            <a:off x="4343400" y="5076443"/>
+            <a:ext cx="822960" cy="347472"/>
+          </a:xfrm>
+          <a:prstGeom prst="rect">
+            <a:avLst/>
+          </a:prstGeom>
+          <a:noFill/>
+        </p:spPr>
+        <p:txBody>
+          <a:bodyPr wrap="square">
+            <a:spAutoFit/>
+          </a:bodyPr>
+          <a:lstStyle/>
+          <a:p>
+            <a:pPr algn="l"/>
+            <a:r>
+              <a:rPr sz="1050" b="0" i="0">
+                <a:solidFill>
+                  <a:srgbClr val="333333"/>
+                </a:solidFill>
+              </a:rPr>
+              <a:t>9</a:t>
+            </a:r>
+          </a:p>
+        </p:txBody>
+      </p:sp>
+      <p:sp>
+        <p:nvSpPr>
+          <p:cNvPr id="63" name="Rectangle 62"/>
+          <p:cNvSpPr/>
+          <p:nvPr/>
+        </p:nvSpPr>
+        <p:spPr>
+          <a:xfrm>
+            <a:off x="5212080" y="5038343"/>
+            <a:ext cx="6492240" cy="347472"/>
+          </a:xfrm>
+          <a:prstGeom prst="rect">
+            <a:avLst/>
+          </a:prstGeom>
+          <a:solidFill>
+            <a:srgbClr val="F7F9FC"/>
+          </a:solidFill>
+          <a:ln>
+            <a:noFill/>
+          </a:ln>
+        </p:spPr>
+        <p:style>
+          <a:lnRef idx="1">
+            <a:schemeClr val="accent1"/>
+          </a:lnRef>
+          <a:fillRef idx="3">
+            <a:schemeClr val="accent1"/>
+          </a:fillRef>
+          <a:effectRef idx="2">
+            <a:schemeClr val="accent1"/>
+          </a:effectRef>
+          <a:fontRef idx="minor">
+            <a:schemeClr val="lt1"/>
+          </a:fontRef>
+        </p:style>
+        <p:txBody>
+          <a:bodyPr rtlCol="0" anchor="ctr"/>
+          <a:lstStyle/>
+          <a:p>
+            <a:pPr algn="ctr"/>
+          </a:p>
+        </p:txBody>
+      </p:sp>
+      <p:sp>
+        <p:nvSpPr>
+          <p:cNvPr id="64" name="TextBox 63"/>
+          <p:cNvSpPr txBox="1"/>
+          <p:nvPr/>
+        </p:nvSpPr>
+        <p:spPr>
+          <a:xfrm>
+            <a:off x="5257800" y="5076443"/>
+            <a:ext cx="6400800" cy="347472"/>
+          </a:xfrm>
+          <a:prstGeom prst="rect">
+            <a:avLst/>
+          </a:prstGeom>
+          <a:noFill/>
+        </p:spPr>
+        <p:txBody>
+          <a:bodyPr wrap="square">
+            <a:spAutoFit/>
+          </a:bodyPr>
+          <a:lstStyle/>
+          <a:p>
+            <a:pPr algn="l"/>
+            <a:r>
+              <a:rPr sz="1050" b="0" i="0">
+                <a:solidFill>
+                  <a:srgbClr val="333333"/>
+                </a:solidFill>
+              </a:rPr>
+              <a:t>Event schema and bad-data injection rates</a:t>
+            </a:r>
+          </a:p>
+        </p:txBody>
+      </p:sp>
+      <p:sp>
+        <p:nvSpPr>
+          <p:cNvPr id="65" name="Rectangle 64"/>
+          <p:cNvSpPr/>
+          <p:nvPr/>
+        </p:nvSpPr>
+        <p:spPr>
+          <a:xfrm>
+            <a:off x="457200" y="5577840"/>
+            <a:ext cx="5120640" cy="914400"/>
+          </a:xfrm>
+          <a:prstGeom prst="rect">
+            <a:avLst/>
+          </a:prstGeom>
+          <a:solidFill>
+            <a:srgbClr val="1E1E2E"/>
+          </a:solidFill>
+          <a:ln>
+            <a:noFill/>
+          </a:ln>
+        </p:spPr>
+        <p:style>
+          <a:lnRef idx="1">
+            <a:schemeClr val="accent1"/>
+          </a:lnRef>
+          <a:fillRef idx="3">
+            <a:schemeClr val="accent1"/>
+          </a:fillRef>
+          <a:effectRef idx="2">
+            <a:schemeClr val="accent1"/>
+          </a:effectRef>
+          <a:fontRef idx="minor">
+            <a:schemeClr val="lt1"/>
+          </a:fontRef>
+        </p:style>
+        <p:txBody>
+          <a:bodyPr rtlCol="0" anchor="ctr"/>
+          <a:lstStyle/>
+          <a:p>
+            <a:pPr algn="ctr"/>
+          </a:p>
+        </p:txBody>
+      </p:sp>
+      <p:sp>
+        <p:nvSpPr>
+          <p:cNvPr id="66" name="Rectangle 65"/>
+          <p:cNvSpPr/>
+          <p:nvPr/>
+        </p:nvSpPr>
+        <p:spPr>
+          <a:xfrm>
+            <a:off x="457200" y="5577840"/>
+            <a:ext cx="50800" cy="914400"/>
+          </a:xfrm>
+          <a:prstGeom prst="rect">
+            <a:avLst/>
+          </a:prstGeom>
+          <a:solidFill>
+            <a:srgbClr val="E94560"/>
+          </a:solidFill>
+          <a:ln>
+            <a:noFill/>
+          </a:ln>
+        </p:spPr>
+        <p:style>
+          <a:lnRef idx="1">
+            <a:schemeClr val="accent1"/>
+          </a:lnRef>
+          <a:fillRef idx="3">
+            <a:schemeClr val="accent1"/>
+          </a:fillRef>
+          <a:effectRef idx="2">
+            <a:schemeClr val="accent1"/>
+          </a:effectRef>
+          <a:fontRef idx="minor">
+            <a:schemeClr val="lt1"/>
+          </a:fontRef>
+        </p:style>
+        <p:txBody>
+          <a:bodyPr rtlCol="0" anchor="ctr"/>
+          <a:lstStyle/>
+          <a:p>
+            <a:pPr algn="ctr"/>
+          </a:p>
+        </p:txBody>
+      </p:sp>
+      <p:sp>
+        <p:nvSpPr>
+          <p:cNvPr id="67" name="TextBox 66"/>
+          <p:cNvSpPr txBox="1"/>
+          <p:nvPr/>
+        </p:nvSpPr>
+        <p:spPr>
+          <a:xfrm>
+            <a:off x="566928" y="5669280"/>
+            <a:ext cx="4956048" cy="731520"/>
           </a:xfrm>
           <a:prstGeom prst="rect">
             <a:avLst/>
@@ -25413,19 +26450,19 @@
           <a:p>
             <a:pPr algn="l"/>
             <a:r>
-              <a:rPr sz="1300">
+              <a:rPr sz="1200">
                 <a:solidFill>
                   <a:srgbClr val="CDD6F4"/>
                 </a:solidFill>
                 <a:latin typeface="Courier New"/>
               </a:rPr>
-              <a:t>$ pytest tests/ -v</a:t>
-            </a:r>
-          </a:p>
-          <a:p>
-            <a:pPr algn="l"/>
-            <a:r>
-              <a:rPr sz="1300">
+              <a:t>$ pytest tests/</a:t>
+            </a:r>
+          </a:p>
+          <a:p>
+            <a:pPr algn="l"/>
+            <a:r>
+              <a:rPr sz="1200">
                 <a:solidFill>
                   <a:srgbClr val="CDD6F4"/>
                 </a:solidFill>
@@ -25437,27 +26474,27 @@
           <a:p>
             <a:pPr algn="l"/>
             <a:r>
-              <a:rPr sz="1300">
+              <a:rPr sz="1200">
                 <a:solidFill>
                   <a:srgbClr val="CDD6F4"/>
                 </a:solidFill>
                 <a:latin typeface="Courier New"/>
               </a:rPr>
-              <a:t>48 passed in 3.21s</a:t>
-            </a:r>
-          </a:p>
-        </p:txBody>
-      </p:sp>
-      <p:sp>
-        <p:nvSpPr>
-          <p:cNvPr id="38" name="TextBox 37"/>
-          <p:cNvSpPr txBox="1"/>
-          <p:nvPr/>
-        </p:nvSpPr>
-        <p:spPr>
-          <a:xfrm>
-            <a:off x="5669280" y="3566160"/>
-            <a:ext cx="6035040" cy="347472"/>
+              <a:t>95 passed (10 Spark-only tests deselected)</a:t>
+            </a:r>
+          </a:p>
+        </p:txBody>
+      </p:sp>
+      <p:sp>
+        <p:nvSpPr>
+          <p:cNvPr id="68" name="TextBox 67"/>
+          <p:cNvSpPr txBox="1"/>
+          <p:nvPr/>
+        </p:nvSpPr>
+        <p:spPr>
+          <a:xfrm>
+            <a:off x="5852160" y="5532120"/>
+            <a:ext cx="5852160" cy="347472"/>
           </a:xfrm>
           <a:prstGeom prst="rect">
             <a:avLst/>
@@ -25484,34 +26521,34 @@
       </p:sp>
       <p:sp>
         <p:nvSpPr>
-          <p:cNvPr id="39" name="TextBox 38"/>
-          <p:cNvSpPr txBox="1"/>
-          <p:nvPr/>
-        </p:nvSpPr>
-        <p:spPr>
-          <a:xfrm>
-            <a:off x="5669280" y="3950208"/>
-            <a:ext cx="6035040" cy="1280160"/>
-          </a:xfrm>
-          <a:prstGeom prst="rect">
-            <a:avLst/>
-          </a:prstGeom>
-          <a:noFill/>
-        </p:spPr>
-        <p:txBody>
-          <a:bodyPr wrap="square">
-            <a:spAutoFit/>
-          </a:bodyPr>
-          <a:lstStyle/>
-          <a:p>
-            <a:pPr algn="l"/>
-            <a:r>
-              <a:rPr sz="1300" b="0" i="0">
+          <p:cNvPr id="69" name="TextBox 68"/>
+          <p:cNvSpPr txBox="1"/>
+          <p:nvPr/>
+        </p:nvSpPr>
+        <p:spPr>
+          <a:xfrm>
+            <a:off x="5852160" y="5870448"/>
+            <a:ext cx="5852160" cy="777240"/>
+          </a:xfrm>
+          <a:prstGeom prst="rect">
+            <a:avLst/>
+          </a:prstGeom>
+          <a:noFill/>
+        </p:spPr>
+        <p:txBody>
+          <a:bodyPr wrap="square">
+            <a:spAutoFit/>
+          </a:bodyPr>
+          <a:lstStyle/>
+          <a:p>
+            <a:pPr algn="l"/>
+            <a:r>
+              <a:rPr sz="1200" b="0" i="0">
                 <a:solidFill>
                   <a:srgbClr val="333333"/>
                 </a:solidFill>
               </a:rPr>
-              <a:t>Pure-Python business logic is extracted from Spark-dependent code, enabling fast offline tests without a running cluster. Spark interactions are mocked at the boundary using unittest.mock.</a:t>
+              <a:t>Pure-Python business logic is separated from Spark code, so most tests run offline without a cluster. Spark calls are mocked at the boundary.</a:t>
             </a:r>
           </a:p>
         </p:txBody>
@@ -26206,7 +27243,7 @@
                   <a:srgbClr val="333333"/>
                 </a:solidFill>
               </a:rPr>
-              <a:t>A ★</a:t>
+              <a:t>A ✅</a:t>
             </a:r>
           </a:p>
         </p:txBody>
@@ -26360,7 +27397,7 @@
                   <a:srgbClr val="333333"/>
                 </a:solidFill>
               </a:rPr>
-              <a:t>AI classifies violation severity → routes alert</a:t>
+              <a:t>Built: spike detection + log + Slack. Next: AI severity</a:t>
             </a:r>
           </a:p>
         </p:txBody>
@@ -27789,7 +28826,7 @@
                   <a:srgbClr val="333333"/>
                 </a:solidFill>
               </a:rPr>
-              <a:t>Recommended next step: A (Alerting) — highest immediate business value, lowest lift. Wires the existing dq_rule_metrics table to a notification layer. No new ML needed.</a:t>
+              <a:t>Stage A is delivered: spike detection and the audit log are verified on Databricks; Slack delivery is ready once the webhook secret is configured. Next: choose among B–E, and add AI severity and plain-English explanations to A.</a:t>
             </a:r>
           </a:p>
         </p:txBody>
@@ -27841,7 +28878,7 @@
                   <a:srgbClr val="0F3460"/>
                 </a:solidFill>
               </a:rPr>
-              <a:t>Opportunity A — Automated Alerting</a:t>
+              <a:t>Stage A — Automated Alerting (Delivered)</a:t>
             </a:r>
           </a:p>
         </p:txBody>
@@ -28041,7 +29078,7 @@
                 </a:solidFill>
                 <a:latin typeface="Courier New"/>
               </a:rPr>
-              <a:t>  Alert Evaluation Engine</a:t>
+              <a:t>  Alert check job (dq_alert_check.py)</a:t>
             </a:r>
           </a:p>
           <a:p>
@@ -28065,7 +29102,7 @@
                 </a:solidFill>
                 <a:latin typeface="Courier New"/>
               </a:rPr>
-              <a:t>  │  if violation_pct &gt; threshold for rule X             │</a:t>
+              <a:t>  │  baseline = avg violation_pct of the last N runs     │</a:t>
             </a:r>
           </a:p>
           <a:p>
@@ -28077,7 +29114,7 @@
                 </a:solidFill>
                 <a:latin typeface="Courier New"/>
               </a:rPr>
-              <a:t>  │  → classify severity (info / warning / critical)     │</a:t>
+              <a:t>  │  spike if last run &gt; max(2.5 × baseline, 5%)         │</a:t>
             </a:r>
           </a:p>
           <a:p>
@@ -28089,7 +29126,7 @@
                 </a:solidFill>
                 <a:latin typeface="Courier New"/>
               </a:rPr>
-              <a:t>  │  → deduplicate (don't re-alert same issue twice)     │</a:t>
+              <a:t>  │  needs at least 3 prior runs for the rule            │</a:t>
             </a:r>
           </a:p>
           <a:p>
@@ -28101,7 +29138,7 @@
                 </a:solidFill>
                 <a:latin typeface="Courier New"/>
               </a:rPr>
-              <a:t>  │  → route to appropriate channel                      │</a:t>
+              <a:t>  │  never re-alert the same rule + run                  │</a:t>
             </a:r>
           </a:p>
           <a:p>
@@ -28125,7 +29162,7 @@
                 </a:solidFill>
                 <a:latin typeface="Courier New"/>
               </a:rPr>
-              <a:t>           ├──► Slack / Teams notification</a:t>
+              <a:t>           ├──► Slack webhook notification</a:t>
             </a:r>
           </a:p>
           <a:p>
@@ -28137,7 +29174,7 @@
                 </a:solidFill>
                 <a:latin typeface="Courier New"/>
               </a:rPr>
-              <a:t>           ├──► PagerDuty / OpsGenie (critical only)</a:t>
+              <a:t>           ├──► dq_alert_log table (full audit trail)</a:t>
             </a:r>
           </a:p>
           <a:p>
@@ -28149,7 +29186,7 @@
                 </a:solidFill>
                 <a:latin typeface="Courier New"/>
               </a:rPr>
-              <a:t>           └──► dq_alerts table (full audit log)</a:t>
+              <a:t>           └──► native Databricks SQL Alert (alternative path)</a:t>
             </a:r>
           </a:p>
         </p:txBody>
@@ -28183,7 +29220,7 @@
                   <a:srgbClr val="0F3460"/>
                 </a:solidFill>
               </a:rPr>
-              <a:t>AI infusion in the alert message:</a:t>
+              <a:t>Next: AI infusion in the alert message</a:t>
             </a:r>
           </a:p>
         </p:txBody>
@@ -28649,7 +29686,7 @@
                   <a:srgbClr val="333333"/>
                 </a:solidFill>
               </a:rPr>
-              <a:t>Existing infrastructure (dq_rule_metrics, LLM backend) is already in place. Alerting is an orchestration layer on top — estimated 1 sprint to ship.</a:t>
+              <a:t>Spike detection and logging are verified end to end on Databricks; Slack delivery is ready once the webhook secret is configured. The LLM backend is already in place for the severity and explanation step.</a:t>
             </a:r>
           </a:p>
         </p:txBody>
@@ -28967,6 +30004,21 @@
               <a:t>  ✅  Human governance layer</a:t>
             </a:r>
           </a:p>
+          <a:p>
+            <a:pPr>
+              <a:spcBef>
+                <a:spcPts val="1600"/>
+              </a:spcBef>
+            </a:pPr>
+            <a:r>
+              <a:rPr sz="1500">
+                <a:solidFill>
+                  <a:srgbClr val="0D522A"/>
+                </a:solidFill>
+              </a:rPr>
+              <a:t>  ✅  Spike alerting with audit log</a:t>
+            </a:r>
+          </a:p>
         </p:txBody>
       </p:sp>
       <p:sp>
@@ -29492,7 +30544,7 @@
                   <a:srgbClr val="333333"/>
                 </a:solidFill>
               </a:rPr>
-              <a:t>•  Which next-stage opportunity (Alerting / Drift / Scorecard) aligns best with delivery priorities?</a:t>
+              <a:t>•  Which next-stage opportunity (Drift / Scorecard / Governance) aligns best with delivery priorities?</a:t>
             </a:r>
           </a:p>
           <a:p>
@@ -29911,7 +30963,7 @@
                   <a:srgbClr val="CCCCCC"/>
                 </a:solidFill>
               </a:rPr>
-              <a:t>5 phases complete  ·  48 unit tests passing  ·  Production-grade architecture  ·  Ready for next phase</a:t>
+              <a:t>5 phases + alerting complete  ·  105 unit tests  ·  Production-grade architecture  ·  Ready for next phase</a:t>
             </a:r>
           </a:p>
         </p:txBody>

</xml_diff>